<commit_message>
Publish a clean public review package for ElimuMatch.
Keep Pages demos, investor brief, pitch, notebook bundle, and proposal articulation; leave Streamlit, drafts, course materials, and old data versions local-only via gitignore.

Co-authored-by: Cursor <cursoragent@cursor.com>
</commit_message>
<xml_diff>
--- a/ElimuMatch_Executive_Pitch.pptx
+++ b/ElimuMatch_Executive_Pitch.pptx
@@ -5,18 +5,18 @@
     <p:sldMasterId id="2147483648" r:id="rId1"/>
   </p:sldMasterIdLst>
   <p:sldIdLst>
-    <p:sldId id="256" r:id="rId7"/>
-    <p:sldId id="257" r:id="rId8"/>
-    <p:sldId id="258" r:id="rId9"/>
-    <p:sldId id="259" r:id="rId10"/>
-    <p:sldId id="260" r:id="rId11"/>
-    <p:sldId id="261" r:id="rId12"/>
-    <p:sldId id="262" r:id="rId13"/>
-    <p:sldId id="263" r:id="rId14"/>
-    <p:sldId id="264" r:id="rId15"/>
-    <p:sldId id="265" r:id="rId16"/>
+    <p:sldId id="256" r:id="rId2"/>
+    <p:sldId id="257" r:id="rId3"/>
+    <p:sldId id="258" r:id="rId4"/>
+    <p:sldId id="259" r:id="rId5"/>
+    <p:sldId id="260" r:id="rId6"/>
+    <p:sldId id="261" r:id="rId7"/>
+    <p:sldId id="262" r:id="rId8"/>
+    <p:sldId id="263" r:id="rId9"/>
+    <p:sldId id="264" r:id="rId10"/>
+    <p:sldId id="265" r:id="rId11"/>
   </p:sldIdLst>
-  <p:sldSz cx="12191695" cy="6858000" type="screen4x3"/>
+  <p:sldSz cx="12192000" cy="6858000"/>
   <p:notesSz cx="6858000" cy="9144000"/>
   <p:defaultTextStyle>
     <a:defPPr>
@@ -113,7 +113,189 @@
       </a:defRPr>
     </a:lvl9pPr>
   </p:defaultTextStyle>
+  <p:extLst>
+    <p:ext uri="{EFAFB233-063F-42B5-8137-9DF3F51BA10A}">
+      <p15:sldGuideLst xmlns:p15="http://schemas.microsoft.com/office/powerpoint/2012/main">
+        <p15:guide id="1" orient="horz" pos="2160">
+          <p15:clr>
+            <a:srgbClr val="A4A3A4"/>
+          </p15:clr>
+        </p15:guide>
+        <p15:guide id="2" pos="2880">
+          <p15:clr>
+            <a:srgbClr val="A4A3A4"/>
+          </p15:clr>
+        </p15:guide>
+      </p15:sldGuideLst>
+    </p:ext>
+  </p:extLst>
 </p:presentation>
+</file>
+
+<file path=ppt/changesInfos/changesInfo1.xml><?xml version="1.0" encoding="utf-8"?>
+<pc:chgInfo xmlns:a="http://schemas.openxmlformats.org/drawingml/2006/main" xmlns:r="http://schemas.openxmlformats.org/officeDocument/2006/relationships" xmlns:ac="http://schemas.microsoft.com/office/drawing/2013/main/command" xmlns:pc="http://schemas.microsoft.com/office/powerpoint/2013/main/command">
+  <pc:docChgLst>
+    <pc:chgData name="Jess W" userId="0a9e92bfc7a9bd4f" providerId="LiveId" clId="{44A44528-DB36-4F8C-9869-CF35F0FB3EAC}"/>
+    <pc:docChg chg="undo custSel modSld">
+      <pc:chgData name="Jess W" userId="0a9e92bfc7a9bd4f" providerId="LiveId" clId="{44A44528-DB36-4F8C-9869-CF35F0FB3EAC}" dt="2026-09-04T20:06:49.613" v="137" actId="20577"/>
+      <pc:docMkLst>
+        <pc:docMk/>
+      </pc:docMkLst>
+      <pc:sldChg chg="modSp mod">
+        <pc:chgData name="Jess W" userId="0a9e92bfc7a9bd4f" providerId="LiveId" clId="{44A44528-DB36-4F8C-9869-CF35F0FB3EAC}" dt="2026-09-04T20:01:41.200" v="127" actId="20577"/>
+        <pc:sldMkLst>
+          <pc:docMk/>
+          <pc:sldMk cId="0" sldId="256"/>
+        </pc:sldMkLst>
+        <pc:spChg chg="mod">
+          <ac:chgData name="Jess W" userId="0a9e92bfc7a9bd4f" providerId="LiveId" clId="{44A44528-DB36-4F8C-9869-CF35F0FB3EAC}" dt="2026-09-04T20:01:41.200" v="127" actId="20577"/>
+          <ac:spMkLst>
+            <pc:docMk/>
+            <pc:sldMk cId="0" sldId="256"/>
+            <ac:spMk id="6" creationId="{00000000-0000-0000-0000-000000000000}"/>
+          </ac:spMkLst>
+        </pc:spChg>
+        <pc:spChg chg="mod">
+          <ac:chgData name="Jess W" userId="0a9e92bfc7a9bd4f" providerId="LiveId" clId="{44A44528-DB36-4F8C-9869-CF35F0FB3EAC}" dt="2026-09-04T19:45:10.437" v="60" actId="20577"/>
+          <ac:spMkLst>
+            <pc:docMk/>
+            <pc:sldMk cId="0" sldId="256"/>
+            <ac:spMk id="8" creationId="{00000000-0000-0000-0000-000000000000}"/>
+          </ac:spMkLst>
+        </pc:spChg>
+        <pc:spChg chg="mod">
+          <ac:chgData name="Jess W" userId="0a9e92bfc7a9bd4f" providerId="LiveId" clId="{44A44528-DB36-4F8C-9869-CF35F0FB3EAC}" dt="2026-09-04T19:44:55.947" v="58" actId="1076"/>
+          <ac:spMkLst>
+            <pc:docMk/>
+            <pc:sldMk cId="0" sldId="256"/>
+            <ac:spMk id="9" creationId="{00000000-0000-0000-0000-000000000000}"/>
+          </ac:spMkLst>
+        </pc:spChg>
+      </pc:sldChg>
+      <pc:sldChg chg="modSp mod">
+        <pc:chgData name="Jess W" userId="0a9e92bfc7a9bd4f" providerId="LiveId" clId="{44A44528-DB36-4F8C-9869-CF35F0FB3EAC}" dt="2026-09-04T20:02:35.120" v="131" actId="20577"/>
+        <pc:sldMkLst>
+          <pc:docMk/>
+          <pc:sldMk cId="0" sldId="257"/>
+        </pc:sldMkLst>
+        <pc:spChg chg="mod">
+          <ac:chgData name="Jess W" userId="0a9e92bfc7a9bd4f" providerId="LiveId" clId="{44A44528-DB36-4F8C-9869-CF35F0FB3EAC}" dt="2026-09-04T20:02:35.120" v="131" actId="20577"/>
+          <ac:spMkLst>
+            <pc:docMk/>
+            <pc:sldMk cId="0" sldId="257"/>
+            <ac:spMk id="5" creationId="{00000000-0000-0000-0000-000000000000}"/>
+          </ac:spMkLst>
+        </pc:spChg>
+      </pc:sldChg>
+      <pc:sldChg chg="delSp modSp mod">
+        <pc:chgData name="Jess W" userId="0a9e92bfc7a9bd4f" providerId="LiveId" clId="{44A44528-DB36-4F8C-9869-CF35F0FB3EAC}" dt="2026-09-04T20:06:27.259" v="134" actId="1076"/>
+        <pc:sldMkLst>
+          <pc:docMk/>
+          <pc:sldMk cId="0" sldId="258"/>
+        </pc:sldMkLst>
+        <pc:spChg chg="mod">
+          <ac:chgData name="Jess W" userId="0a9e92bfc7a9bd4f" providerId="LiveId" clId="{44A44528-DB36-4F8C-9869-CF35F0FB3EAC}" dt="2026-09-04T20:06:27.259" v="134" actId="1076"/>
+          <ac:spMkLst>
+            <pc:docMk/>
+            <pc:sldMk cId="0" sldId="258"/>
+            <ac:spMk id="7" creationId="{00000000-0000-0000-0000-000000000000}"/>
+          </ac:spMkLst>
+        </pc:spChg>
+        <pc:spChg chg="del">
+          <ac:chgData name="Jess W" userId="0a9e92bfc7a9bd4f" providerId="LiveId" clId="{44A44528-DB36-4F8C-9869-CF35F0FB3EAC}" dt="2026-09-04T20:06:17.389" v="132" actId="478"/>
+          <ac:spMkLst>
+            <pc:docMk/>
+            <pc:sldMk cId="0" sldId="258"/>
+            <ac:spMk id="8" creationId="{00000000-0000-0000-0000-000000000000}"/>
+          </ac:spMkLst>
+        </pc:spChg>
+      </pc:sldChg>
+      <pc:sldChg chg="modSp mod">
+        <pc:chgData name="Jess W" userId="0a9e92bfc7a9bd4f" providerId="LiveId" clId="{44A44528-DB36-4F8C-9869-CF35F0FB3EAC}" dt="2026-09-04T20:06:49.613" v="137" actId="20577"/>
+        <pc:sldMkLst>
+          <pc:docMk/>
+          <pc:sldMk cId="0" sldId="259"/>
+        </pc:sldMkLst>
+        <pc:spChg chg="mod">
+          <ac:chgData name="Jess W" userId="0a9e92bfc7a9bd4f" providerId="LiveId" clId="{44A44528-DB36-4F8C-9869-CF35F0FB3EAC}" dt="2026-09-04T20:06:49.613" v="137" actId="20577"/>
+          <ac:spMkLst>
+            <pc:docMk/>
+            <pc:sldMk cId="0" sldId="259"/>
+            <ac:spMk id="8" creationId="{00000000-0000-0000-0000-000000000000}"/>
+          </ac:spMkLst>
+        </pc:spChg>
+      </pc:sldChg>
+      <pc:sldChg chg="modSp mod">
+        <pc:chgData name="Jess W" userId="0a9e92bfc7a9bd4f" providerId="LiveId" clId="{44A44528-DB36-4F8C-9869-CF35F0FB3EAC}" dt="2026-09-04T19:43:16.883" v="13" actId="20577"/>
+        <pc:sldMkLst>
+          <pc:docMk/>
+          <pc:sldMk cId="0" sldId="261"/>
+        </pc:sldMkLst>
+        <pc:spChg chg="mod">
+          <ac:chgData name="Jess W" userId="0a9e92bfc7a9bd4f" providerId="LiveId" clId="{44A44528-DB36-4F8C-9869-CF35F0FB3EAC}" dt="2026-09-04T19:43:16.883" v="13" actId="20577"/>
+          <ac:spMkLst>
+            <pc:docMk/>
+            <pc:sldMk cId="0" sldId="261"/>
+            <ac:spMk id="8" creationId="{00000000-0000-0000-0000-000000000000}"/>
+          </ac:spMkLst>
+        </pc:spChg>
+      </pc:sldChg>
+      <pc:sldChg chg="modSp mod">
+        <pc:chgData name="Jess W" userId="0a9e92bfc7a9bd4f" providerId="LiveId" clId="{44A44528-DB36-4F8C-9869-CF35F0FB3EAC}" dt="2026-09-04T19:43:04.010" v="11" actId="20577"/>
+        <pc:sldMkLst>
+          <pc:docMk/>
+          <pc:sldMk cId="0" sldId="262"/>
+        </pc:sldMkLst>
+        <pc:spChg chg="mod">
+          <ac:chgData name="Jess W" userId="0a9e92bfc7a9bd4f" providerId="LiveId" clId="{44A44528-DB36-4F8C-9869-CF35F0FB3EAC}" dt="2026-09-04T19:43:04.010" v="11" actId="20577"/>
+          <ac:spMkLst>
+            <pc:docMk/>
+            <pc:sldMk cId="0" sldId="262"/>
+            <ac:spMk id="8" creationId="{00000000-0000-0000-0000-000000000000}"/>
+          </ac:spMkLst>
+        </pc:spChg>
+      </pc:sldChg>
+      <pc:sldChg chg="modSp mod">
+        <pc:chgData name="Jess W" userId="0a9e92bfc7a9bd4f" providerId="LiveId" clId="{44A44528-DB36-4F8C-9869-CF35F0FB3EAC}" dt="2026-09-04T19:41:38.795" v="7" actId="20577"/>
+        <pc:sldMkLst>
+          <pc:docMk/>
+          <pc:sldMk cId="0" sldId="263"/>
+        </pc:sldMkLst>
+        <pc:spChg chg="mod">
+          <ac:chgData name="Jess W" userId="0a9e92bfc7a9bd4f" providerId="LiveId" clId="{44A44528-DB36-4F8C-9869-CF35F0FB3EAC}" dt="2026-09-04T19:41:38.795" v="7" actId="20577"/>
+          <ac:spMkLst>
+            <pc:docMk/>
+            <pc:sldMk cId="0" sldId="263"/>
+            <ac:spMk id="9" creationId="{00000000-0000-0000-0000-000000000000}"/>
+          </ac:spMkLst>
+        </pc:spChg>
+        <pc:spChg chg="mod">
+          <ac:chgData name="Jess W" userId="0a9e92bfc7a9bd4f" providerId="LiveId" clId="{44A44528-DB36-4F8C-9869-CF35F0FB3EAC}" dt="2026-09-04T19:40:43.410" v="3" actId="6549"/>
+          <ac:spMkLst>
+            <pc:docMk/>
+            <pc:sldMk cId="0" sldId="263"/>
+            <ac:spMk id="12" creationId="{00000000-0000-0000-0000-000000000000}"/>
+          </ac:spMkLst>
+        </pc:spChg>
+      </pc:sldChg>
+      <pc:sldChg chg="modSp mod">
+        <pc:chgData name="Jess W" userId="0a9e92bfc7a9bd4f" providerId="LiveId" clId="{44A44528-DB36-4F8C-9869-CF35F0FB3EAC}" dt="2026-09-04T19:43:50.354" v="15" actId="20577"/>
+        <pc:sldMkLst>
+          <pc:docMk/>
+          <pc:sldMk cId="0" sldId="265"/>
+        </pc:sldMkLst>
+        <pc:spChg chg="mod">
+          <ac:chgData name="Jess W" userId="0a9e92bfc7a9bd4f" providerId="LiveId" clId="{44A44528-DB36-4F8C-9869-CF35F0FB3EAC}" dt="2026-09-04T19:43:50.354" v="15" actId="20577"/>
+          <ac:spMkLst>
+            <pc:docMk/>
+            <pc:sldMk cId="0" sldId="265"/>
+            <ac:spMk id="7" creationId="{00000000-0000-0000-0000-000000000000}"/>
+          </ac:spMkLst>
+        </pc:spChg>
+      </pc:sldChg>
+    </pc:docChg>
+  </pc:docChgLst>
+</pc:chgInfo>
 </file>
 
 <file path=ppt/slideLayouts/slideLayout1.xml><?xml version="1.0" encoding="utf-8"?>
@@ -154,10 +336,9 @@
           <a:lstStyle/>
           <a:p>
             <a:r>
-              <a:rPr lang="en-US" smtClean="0"/>
+              <a:rPr lang="en-US"/>
               <a:t>Click to edit Master title style</a:t>
             </a:r>
-            <a:endParaRPr lang="en-US"/>
           </a:p>
         </p:txBody>
       </p:sp>
@@ -273,10 +454,9 @@
           </a:lstStyle>
           <a:p>
             <a:r>
-              <a:rPr lang="en-US" smtClean="0"/>
+              <a:rPr lang="en-US"/>
               <a:t>Click to edit Master subtitle style</a:t>
             </a:r>
-            <a:endParaRPr lang="en-US"/>
           </a:p>
         </p:txBody>
       </p:sp>
@@ -297,7 +477,7 @@
           <a:p>
             <a:fld id="{5BCAD085-E8A6-8845-BD4E-CB4CCA059FC4}" type="datetimeFigureOut">
               <a:rPr lang="en-US" smtClean="0"/>
-              <a:t>1/27/13</a:t>
+              <a:t>9/4/2026</a:t>
             </a:fld>
             <a:endParaRPr lang="en-US"/>
           </a:p>
@@ -391,10 +571,9 @@
           <a:lstStyle/>
           <a:p>
             <a:r>
-              <a:rPr lang="en-US" smtClean="0"/>
+              <a:rPr lang="en-US"/>
               <a:t>Click to edit Master title style</a:t>
             </a:r>
-            <a:endParaRPr lang="en-US"/>
           </a:p>
         </p:txBody>
       </p:sp>
@@ -415,38 +594,37 @@
           <a:p>
             <a:pPr lvl="0"/>
             <a:r>
-              <a:rPr lang="en-US" smtClean="0"/>
+              <a:rPr lang="en-US"/>
               <a:t>Click to edit Master text styles</a:t>
             </a:r>
           </a:p>
           <a:p>
             <a:pPr lvl="1"/>
             <a:r>
-              <a:rPr lang="en-US" smtClean="0"/>
+              <a:rPr lang="en-US"/>
               <a:t>Second level</a:t>
             </a:r>
           </a:p>
           <a:p>
             <a:pPr lvl="2"/>
             <a:r>
-              <a:rPr lang="en-US" smtClean="0"/>
+              <a:rPr lang="en-US"/>
               <a:t>Third level</a:t>
             </a:r>
           </a:p>
           <a:p>
             <a:pPr lvl="3"/>
             <a:r>
-              <a:rPr lang="en-US" smtClean="0"/>
+              <a:rPr lang="en-US"/>
               <a:t>Fourth level</a:t>
             </a:r>
           </a:p>
           <a:p>
             <a:pPr lvl="4"/>
             <a:r>
-              <a:rPr lang="en-US" smtClean="0"/>
+              <a:rPr lang="en-US"/>
               <a:t>Fifth level</a:t>
             </a:r>
-            <a:endParaRPr lang="en-US"/>
           </a:p>
         </p:txBody>
       </p:sp>
@@ -467,7 +645,7 @@
           <a:p>
             <a:fld id="{5BCAD085-E8A6-8845-BD4E-CB4CCA059FC4}" type="datetimeFigureOut">
               <a:rPr lang="en-US" smtClean="0"/>
-              <a:t>1/27/13</a:t>
+              <a:t>9/4/2026</a:t>
             </a:fld>
             <a:endParaRPr lang="en-US"/>
           </a:p>
@@ -566,10 +744,9 @@
           <a:lstStyle/>
           <a:p>
             <a:r>
-              <a:rPr lang="en-US" smtClean="0"/>
+              <a:rPr lang="en-US"/>
               <a:t>Click to edit Master title style</a:t>
             </a:r>
-            <a:endParaRPr lang="en-US"/>
           </a:p>
         </p:txBody>
       </p:sp>
@@ -595,38 +772,37 @@
           <a:p>
             <a:pPr lvl="0"/>
             <a:r>
-              <a:rPr lang="en-US" smtClean="0"/>
+              <a:rPr lang="en-US"/>
               <a:t>Click to edit Master text styles</a:t>
             </a:r>
           </a:p>
           <a:p>
             <a:pPr lvl="1"/>
             <a:r>
-              <a:rPr lang="en-US" smtClean="0"/>
+              <a:rPr lang="en-US"/>
               <a:t>Second level</a:t>
             </a:r>
           </a:p>
           <a:p>
             <a:pPr lvl="2"/>
             <a:r>
-              <a:rPr lang="en-US" smtClean="0"/>
+              <a:rPr lang="en-US"/>
               <a:t>Third level</a:t>
             </a:r>
           </a:p>
           <a:p>
             <a:pPr lvl="3"/>
             <a:r>
-              <a:rPr lang="en-US" smtClean="0"/>
+              <a:rPr lang="en-US"/>
               <a:t>Fourth level</a:t>
             </a:r>
           </a:p>
           <a:p>
             <a:pPr lvl="4"/>
             <a:r>
-              <a:rPr lang="en-US" smtClean="0"/>
+              <a:rPr lang="en-US"/>
               <a:t>Fifth level</a:t>
             </a:r>
-            <a:endParaRPr lang="en-US"/>
           </a:p>
         </p:txBody>
       </p:sp>
@@ -647,7 +823,7 @@
           <a:p>
             <a:fld id="{5BCAD085-E8A6-8845-BD4E-CB4CCA059FC4}" type="datetimeFigureOut">
               <a:rPr lang="en-US" smtClean="0"/>
-              <a:t>1/27/13</a:t>
+              <a:t>9/4/2026</a:t>
             </a:fld>
             <a:endParaRPr lang="en-US"/>
           </a:p>
@@ -741,10 +917,9 @@
           <a:lstStyle/>
           <a:p>
             <a:r>
-              <a:rPr lang="en-US" smtClean="0"/>
+              <a:rPr lang="en-US"/>
               <a:t>Click to edit Master title style</a:t>
             </a:r>
-            <a:endParaRPr lang="en-US"/>
           </a:p>
         </p:txBody>
       </p:sp>
@@ -765,38 +940,37 @@
           <a:p>
             <a:pPr lvl="0"/>
             <a:r>
-              <a:rPr lang="en-US" smtClean="0"/>
+              <a:rPr lang="en-US"/>
               <a:t>Click to edit Master text styles</a:t>
             </a:r>
           </a:p>
           <a:p>
             <a:pPr lvl="1"/>
             <a:r>
-              <a:rPr lang="en-US" smtClean="0"/>
+              <a:rPr lang="en-US"/>
               <a:t>Second level</a:t>
             </a:r>
           </a:p>
           <a:p>
             <a:pPr lvl="2"/>
             <a:r>
-              <a:rPr lang="en-US" smtClean="0"/>
+              <a:rPr lang="en-US"/>
               <a:t>Third level</a:t>
             </a:r>
           </a:p>
           <a:p>
             <a:pPr lvl="3"/>
             <a:r>
-              <a:rPr lang="en-US" smtClean="0"/>
+              <a:rPr lang="en-US"/>
               <a:t>Fourth level</a:t>
             </a:r>
           </a:p>
           <a:p>
             <a:pPr lvl="4"/>
             <a:r>
-              <a:rPr lang="en-US" smtClean="0"/>
+              <a:rPr lang="en-US"/>
               <a:t>Fifth level</a:t>
             </a:r>
-            <a:endParaRPr lang="en-US"/>
           </a:p>
         </p:txBody>
       </p:sp>
@@ -817,7 +991,7 @@
           <a:p>
             <a:fld id="{5BCAD085-E8A6-8845-BD4E-CB4CCA059FC4}" type="datetimeFigureOut">
               <a:rPr lang="en-US" smtClean="0"/>
-              <a:t>1/27/13</a:t>
+              <a:t>9/4/2026</a:t>
             </a:fld>
             <a:endParaRPr lang="en-US"/>
           </a:p>
@@ -920,10 +1094,9 @@
           </a:lstStyle>
           <a:p>
             <a:r>
-              <a:rPr lang="en-US" smtClean="0"/>
+              <a:rPr lang="en-US"/>
               <a:t>Click to edit Master title style</a:t>
             </a:r>
-            <a:endParaRPr lang="en-US"/>
           </a:p>
         </p:txBody>
       </p:sp>
@@ -1040,7 +1213,7 @@
           <a:p>
             <a:pPr lvl="0"/>
             <a:r>
-              <a:rPr lang="en-US" smtClean="0"/>
+              <a:rPr lang="en-US"/>
               <a:t>Click to edit Master text styles</a:t>
             </a:r>
           </a:p>
@@ -1063,7 +1236,7 @@
           <a:p>
             <a:fld id="{5BCAD085-E8A6-8845-BD4E-CB4CCA059FC4}" type="datetimeFigureOut">
               <a:rPr lang="en-US" smtClean="0"/>
-              <a:t>1/27/13</a:t>
+              <a:t>9/4/2026</a:t>
             </a:fld>
             <a:endParaRPr lang="en-US"/>
           </a:p>
@@ -1157,10 +1330,9 @@
           <a:lstStyle/>
           <a:p>
             <a:r>
-              <a:rPr lang="en-US" smtClean="0"/>
+              <a:rPr lang="en-US"/>
               <a:t>Click to edit Master title style</a:t>
             </a:r>
-            <a:endParaRPr lang="en-US"/>
           </a:p>
         </p:txBody>
       </p:sp>
@@ -1214,38 +1386,37 @@
           <a:p>
             <a:pPr lvl="0"/>
             <a:r>
-              <a:rPr lang="en-US" smtClean="0"/>
+              <a:rPr lang="en-US"/>
               <a:t>Click to edit Master text styles</a:t>
             </a:r>
           </a:p>
           <a:p>
             <a:pPr lvl="1"/>
             <a:r>
-              <a:rPr lang="en-US" smtClean="0"/>
+              <a:rPr lang="en-US"/>
               <a:t>Second level</a:t>
             </a:r>
           </a:p>
           <a:p>
             <a:pPr lvl="2"/>
             <a:r>
-              <a:rPr lang="en-US" smtClean="0"/>
+              <a:rPr lang="en-US"/>
               <a:t>Third level</a:t>
             </a:r>
           </a:p>
           <a:p>
             <a:pPr lvl="3"/>
             <a:r>
-              <a:rPr lang="en-US" smtClean="0"/>
+              <a:rPr lang="en-US"/>
               <a:t>Fourth level</a:t>
             </a:r>
           </a:p>
           <a:p>
             <a:pPr lvl="4"/>
             <a:r>
-              <a:rPr lang="en-US" smtClean="0"/>
+              <a:rPr lang="en-US"/>
               <a:t>Fifth level</a:t>
             </a:r>
-            <a:endParaRPr lang="en-US"/>
           </a:p>
         </p:txBody>
       </p:sp>
@@ -1299,38 +1470,37 @@
           <a:p>
             <a:pPr lvl="0"/>
             <a:r>
-              <a:rPr lang="en-US" smtClean="0"/>
+              <a:rPr lang="en-US"/>
               <a:t>Click to edit Master text styles</a:t>
             </a:r>
           </a:p>
           <a:p>
             <a:pPr lvl="1"/>
             <a:r>
-              <a:rPr lang="en-US" smtClean="0"/>
+              <a:rPr lang="en-US"/>
               <a:t>Second level</a:t>
             </a:r>
           </a:p>
           <a:p>
             <a:pPr lvl="2"/>
             <a:r>
-              <a:rPr lang="en-US" smtClean="0"/>
+              <a:rPr lang="en-US"/>
               <a:t>Third level</a:t>
             </a:r>
           </a:p>
           <a:p>
             <a:pPr lvl="3"/>
             <a:r>
-              <a:rPr lang="en-US" smtClean="0"/>
+              <a:rPr lang="en-US"/>
               <a:t>Fourth level</a:t>
             </a:r>
           </a:p>
           <a:p>
             <a:pPr lvl="4"/>
             <a:r>
-              <a:rPr lang="en-US" smtClean="0"/>
+              <a:rPr lang="en-US"/>
               <a:t>Fifth level</a:t>
             </a:r>
-            <a:endParaRPr lang="en-US"/>
           </a:p>
         </p:txBody>
       </p:sp>
@@ -1351,7 +1521,7 @@
           <a:p>
             <a:fld id="{5BCAD085-E8A6-8845-BD4E-CB4CCA059FC4}" type="datetimeFigureOut">
               <a:rPr lang="en-US" smtClean="0"/>
-              <a:t>1/27/13</a:t>
+              <a:t>9/4/2026</a:t>
             </a:fld>
             <a:endParaRPr lang="en-US"/>
           </a:p>
@@ -1449,10 +1619,9 @@
           </a:lstStyle>
           <a:p>
             <a:r>
-              <a:rPr lang="en-US" smtClean="0"/>
+              <a:rPr lang="en-US"/>
               <a:t>Click to edit Master title style</a:t>
             </a:r>
-            <a:endParaRPr lang="en-US"/>
           </a:p>
         </p:txBody>
       </p:sp>
@@ -1515,7 +1684,7 @@
           <a:p>
             <a:pPr lvl="0"/>
             <a:r>
-              <a:rPr lang="en-US" smtClean="0"/>
+              <a:rPr lang="en-US"/>
               <a:t>Click to edit Master text styles</a:t>
             </a:r>
           </a:p>
@@ -1571,38 +1740,37 @@
           <a:p>
             <a:pPr lvl="0"/>
             <a:r>
-              <a:rPr lang="en-US" smtClean="0"/>
+              <a:rPr lang="en-US"/>
               <a:t>Click to edit Master text styles</a:t>
             </a:r>
           </a:p>
           <a:p>
             <a:pPr lvl="1"/>
             <a:r>
-              <a:rPr lang="en-US" smtClean="0"/>
+              <a:rPr lang="en-US"/>
               <a:t>Second level</a:t>
             </a:r>
           </a:p>
           <a:p>
             <a:pPr lvl="2"/>
             <a:r>
-              <a:rPr lang="en-US" smtClean="0"/>
+              <a:rPr lang="en-US"/>
               <a:t>Third level</a:t>
             </a:r>
           </a:p>
           <a:p>
             <a:pPr lvl="3"/>
             <a:r>
-              <a:rPr lang="en-US" smtClean="0"/>
+              <a:rPr lang="en-US"/>
               <a:t>Fourth level</a:t>
             </a:r>
           </a:p>
           <a:p>
             <a:pPr lvl="4"/>
             <a:r>
-              <a:rPr lang="en-US" smtClean="0"/>
+              <a:rPr lang="en-US"/>
               <a:t>Fifth level</a:t>
             </a:r>
-            <a:endParaRPr lang="en-US"/>
           </a:p>
         </p:txBody>
       </p:sp>
@@ -1665,7 +1833,7 @@
           <a:p>
             <a:pPr lvl="0"/>
             <a:r>
-              <a:rPr lang="en-US" smtClean="0"/>
+              <a:rPr lang="en-US"/>
               <a:t>Click to edit Master text styles</a:t>
             </a:r>
           </a:p>
@@ -1721,38 +1889,37 @@
           <a:p>
             <a:pPr lvl="0"/>
             <a:r>
-              <a:rPr lang="en-US" smtClean="0"/>
+              <a:rPr lang="en-US"/>
               <a:t>Click to edit Master text styles</a:t>
             </a:r>
           </a:p>
           <a:p>
             <a:pPr lvl="1"/>
             <a:r>
-              <a:rPr lang="en-US" smtClean="0"/>
+              <a:rPr lang="en-US"/>
               <a:t>Second level</a:t>
             </a:r>
           </a:p>
           <a:p>
             <a:pPr lvl="2"/>
             <a:r>
-              <a:rPr lang="en-US" smtClean="0"/>
+              <a:rPr lang="en-US"/>
               <a:t>Third level</a:t>
             </a:r>
           </a:p>
           <a:p>
             <a:pPr lvl="3"/>
             <a:r>
-              <a:rPr lang="en-US" smtClean="0"/>
+              <a:rPr lang="en-US"/>
               <a:t>Fourth level</a:t>
             </a:r>
           </a:p>
           <a:p>
             <a:pPr lvl="4"/>
             <a:r>
-              <a:rPr lang="en-US" smtClean="0"/>
+              <a:rPr lang="en-US"/>
               <a:t>Fifth level</a:t>
             </a:r>
-            <a:endParaRPr lang="en-US"/>
           </a:p>
         </p:txBody>
       </p:sp>
@@ -1773,7 +1940,7 @@
           <a:p>
             <a:fld id="{5BCAD085-E8A6-8845-BD4E-CB4CCA059FC4}" type="datetimeFigureOut">
               <a:rPr lang="en-US" smtClean="0"/>
-              <a:t>1/27/13</a:t>
+              <a:t>9/4/2026</a:t>
             </a:fld>
             <a:endParaRPr lang="en-US"/>
           </a:p>
@@ -1867,10 +2034,9 @@
           <a:lstStyle/>
           <a:p>
             <a:r>
-              <a:rPr lang="en-US" smtClean="0"/>
+              <a:rPr lang="en-US"/>
               <a:t>Click to edit Master title style</a:t>
             </a:r>
-            <a:endParaRPr lang="en-US"/>
           </a:p>
         </p:txBody>
       </p:sp>
@@ -1891,7 +2057,7 @@
           <a:p>
             <a:fld id="{5BCAD085-E8A6-8845-BD4E-CB4CCA059FC4}" type="datetimeFigureOut">
               <a:rPr lang="en-US" smtClean="0"/>
-              <a:t>1/27/13</a:t>
+              <a:t>9/4/2026</a:t>
             </a:fld>
             <a:endParaRPr lang="en-US"/>
           </a:p>
@@ -1986,7 +2152,7 @@
           <a:p>
             <a:fld id="{5BCAD085-E8A6-8845-BD4E-CB4CCA059FC4}" type="datetimeFigureOut">
               <a:rPr lang="en-US" smtClean="0"/>
-              <a:t>1/27/13</a:t>
+              <a:t>9/4/2026</a:t>
             </a:fld>
             <a:endParaRPr lang="en-US"/>
           </a:p>
@@ -2089,10 +2255,9 @@
           </a:lstStyle>
           <a:p>
             <a:r>
-              <a:rPr lang="en-US" smtClean="0"/>
+              <a:rPr lang="en-US"/>
               <a:t>Click to edit Master title style</a:t>
             </a:r>
-            <a:endParaRPr lang="en-US"/>
           </a:p>
         </p:txBody>
       </p:sp>
@@ -2146,38 +2311,37 @@
           <a:p>
             <a:pPr lvl="0"/>
             <a:r>
-              <a:rPr lang="en-US" smtClean="0"/>
+              <a:rPr lang="en-US"/>
               <a:t>Click to edit Master text styles</a:t>
             </a:r>
           </a:p>
           <a:p>
             <a:pPr lvl="1"/>
             <a:r>
-              <a:rPr lang="en-US" smtClean="0"/>
+              <a:rPr lang="en-US"/>
               <a:t>Second level</a:t>
             </a:r>
           </a:p>
           <a:p>
             <a:pPr lvl="2"/>
             <a:r>
-              <a:rPr lang="en-US" smtClean="0"/>
+              <a:rPr lang="en-US"/>
               <a:t>Third level</a:t>
             </a:r>
           </a:p>
           <a:p>
             <a:pPr lvl="3"/>
             <a:r>
-              <a:rPr lang="en-US" smtClean="0"/>
+              <a:rPr lang="en-US"/>
               <a:t>Fourth level</a:t>
             </a:r>
           </a:p>
           <a:p>
             <a:pPr lvl="4"/>
             <a:r>
-              <a:rPr lang="en-US" smtClean="0"/>
+              <a:rPr lang="en-US"/>
               <a:t>Fifth level</a:t>
             </a:r>
-            <a:endParaRPr lang="en-US"/>
           </a:p>
         </p:txBody>
       </p:sp>
@@ -2240,7 +2404,7 @@
           <a:p>
             <a:pPr lvl="0"/>
             <a:r>
-              <a:rPr lang="en-US" smtClean="0"/>
+              <a:rPr lang="en-US"/>
               <a:t>Click to edit Master text styles</a:t>
             </a:r>
           </a:p>
@@ -2263,7 +2427,7 @@
           <a:p>
             <a:fld id="{5BCAD085-E8A6-8845-BD4E-CB4CCA059FC4}" type="datetimeFigureOut">
               <a:rPr lang="en-US" smtClean="0"/>
-              <a:t>1/27/13</a:t>
+              <a:t>9/4/2026</a:t>
             </a:fld>
             <a:endParaRPr lang="en-US"/>
           </a:p>
@@ -2366,10 +2530,9 @@
           </a:lstStyle>
           <a:p>
             <a:r>
-              <a:rPr lang="en-US" smtClean="0"/>
+              <a:rPr lang="en-US"/>
               <a:t>Click to edit Master title style</a:t>
             </a:r>
-            <a:endParaRPr lang="en-US"/>
           </a:p>
         </p:txBody>
       </p:sp>
@@ -2493,7 +2656,7 @@
           <a:p>
             <a:pPr lvl="0"/>
             <a:r>
-              <a:rPr lang="en-US" smtClean="0"/>
+              <a:rPr lang="en-US"/>
               <a:t>Click to edit Master text styles</a:t>
             </a:r>
           </a:p>
@@ -2516,7 +2679,7 @@
           <a:p>
             <a:fld id="{5BCAD085-E8A6-8845-BD4E-CB4CCA059FC4}" type="datetimeFigureOut">
               <a:rPr lang="en-US" smtClean="0"/>
-              <a:t>1/27/13</a:t>
+              <a:t>9/4/2026</a:t>
             </a:fld>
             <a:endParaRPr lang="en-US"/>
           </a:p>
@@ -2625,10 +2788,9 @@
           <a:lstStyle/>
           <a:p>
             <a:r>
-              <a:rPr lang="en-US" smtClean="0"/>
+              <a:rPr lang="en-US"/>
               <a:t>Click to edit Master title style</a:t>
             </a:r>
-            <a:endParaRPr lang="en-US"/>
           </a:p>
         </p:txBody>
       </p:sp>
@@ -2659,38 +2821,37 @@
           <a:p>
             <a:pPr lvl="0"/>
             <a:r>
-              <a:rPr lang="en-US" smtClean="0"/>
+              <a:rPr lang="en-US"/>
               <a:t>Click to edit Master text styles</a:t>
             </a:r>
           </a:p>
           <a:p>
             <a:pPr lvl="1"/>
             <a:r>
-              <a:rPr lang="en-US" smtClean="0"/>
+              <a:rPr lang="en-US"/>
               <a:t>Second level</a:t>
             </a:r>
           </a:p>
           <a:p>
             <a:pPr lvl="2"/>
             <a:r>
-              <a:rPr lang="en-US" smtClean="0"/>
+              <a:rPr lang="en-US"/>
               <a:t>Third level</a:t>
             </a:r>
           </a:p>
           <a:p>
             <a:pPr lvl="3"/>
             <a:r>
-              <a:rPr lang="en-US" smtClean="0"/>
+              <a:rPr lang="en-US"/>
               <a:t>Fourth level</a:t>
             </a:r>
           </a:p>
           <a:p>
             <a:pPr lvl="4"/>
             <a:r>
-              <a:rPr lang="en-US" smtClean="0"/>
+              <a:rPr lang="en-US"/>
               <a:t>Fifth level</a:t>
             </a:r>
-            <a:endParaRPr lang="en-US"/>
           </a:p>
         </p:txBody>
       </p:sp>
@@ -2729,7 +2890,7 @@
           <a:p>
             <a:fld id="{5BCAD085-E8A6-8845-BD4E-CB4CCA059FC4}" type="datetimeFigureOut">
               <a:rPr lang="en-US" smtClean="0"/>
-              <a:t>1/27/13</a:t>
+              <a:t>9/4/2026</a:t>
             </a:fld>
             <a:endParaRPr lang="en-US"/>
           </a:p>
@@ -3088,7 +3249,7 @@
 </file>
 
 <file path=ppt/slides/slide1.xml><?xml version="1.0" encoding="utf-8"?>
-<p:sld xmlns:a="http://schemas.openxmlformats.org/drawingml/2006/main" xmlns:p="http://schemas.openxmlformats.org/presentationml/2006/main" xmlns:r="http://schemas.openxmlformats.org/officeDocument/2006/relationships">
+<p:sld xmlns:a="http://schemas.openxmlformats.org/drawingml/2006/main" xmlns:r="http://schemas.openxmlformats.org/officeDocument/2006/relationships" xmlns:p="http://schemas.openxmlformats.org/presentationml/2006/main">
   <p:cSld>
     <p:bg>
       <p:bgPr>
@@ -3104,7 +3265,14 @@
         <p:cNvGrpSpPr/>
         <p:nvPr/>
       </p:nvGrpSpPr>
-      <p:grpSpPr/>
+      <p:grpSpPr>
+        <a:xfrm>
+          <a:off x="0" y="0"/>
+          <a:ext cx="0" cy="0"/>
+          <a:chOff x="0" y="0"/>
+          <a:chExt cx="0" cy="0"/>
+        </a:xfrm>
+      </p:grpSpPr>
       <p:sp>
         <p:nvSpPr>
           <p:cNvPr id="2" name="Rectangle 1"/>
@@ -3145,6 +3313,7 @@
           <a:lstStyle/>
           <a:p>
             <a:pPr algn="ctr"/>
+            <a:endParaRPr/>
           </a:p>
         </p:txBody>
       </p:sp>
@@ -3188,6 +3357,7 @@
           <a:lstStyle/>
           <a:p>
             <a:pPr algn="ctr"/>
+            <a:endParaRPr/>
           </a:p>
         </p:txBody>
       </p:sp>
@@ -3272,7 +3442,7 @@
         <p:spPr>
           <a:xfrm>
             <a:off x="1371600" y="3200400"/>
-            <a:ext cx="9144000" cy="457200"/>
+            <a:ext cx="9144000" cy="338554"/>
           </a:xfrm>
           <a:prstGeom prst="rect">
             <a:avLst/>
@@ -3294,7 +3464,16 @@
               </a:defRPr>
             </a:pPr>
             <a:r>
-              <a:t>A data-driven platform for fee support to Kenyan secondary students</a:t>
+              <a:rPr dirty="0"/>
+              <a:t>A data-driven platform for fee support to </a:t>
+            </a:r>
+            <a:r>
+              <a:rPr lang="en-GB" dirty="0"/>
+              <a:t>secondary school students in </a:t>
+            </a:r>
+            <a:r>
+              <a:rPr dirty="0"/>
+              <a:t>Kenya</a:t>
             </a:r>
           </a:p>
         </p:txBody>
@@ -3330,6 +3509,7 @@
               </a:defRPr>
             </a:pPr>
             <a:r>
+              <a:rPr dirty="0"/>
               <a:t>Prepared for Impact Investors, CSR Partners, and Education Foundations</a:t>
             </a:r>
           </a:p>
@@ -3343,8 +3523,8 @@
         </p:nvSpPr>
         <p:spPr>
           <a:xfrm>
-            <a:off x="1371600" y="4937760"/>
-            <a:ext cx="9144000" cy="365760"/>
+            <a:off x="1371600" y="5361503"/>
+            <a:ext cx="9144000" cy="307777"/>
           </a:xfrm>
           <a:prstGeom prst="rect">
             <a:avLst/>
@@ -3366,7 +3546,16 @@
               </a:defRPr>
             </a:pPr>
             <a:r>
-              <a:t>Jesyldah  |  Founder  |  August 2026</a:t>
+              <a:rPr lang="en-GB" dirty="0" err="1"/>
+              <a:t>ElimuMatch</a:t>
+            </a:r>
+            <a:r>
+              <a:rPr lang="en-GB" dirty="0"/>
+              <a:t> Analytics </a:t>
+            </a:r>
+            <a:r>
+              <a:rPr dirty="0"/>
+              <a:t>|  August 2026</a:t>
             </a:r>
           </a:p>
         </p:txBody>
@@ -3379,7 +3568,7 @@
         </p:nvSpPr>
         <p:spPr>
           <a:xfrm>
-            <a:off x="1371600" y="5669280"/>
+            <a:off x="1371600" y="5852160"/>
             <a:ext cx="9144000" cy="365760"/>
           </a:xfrm>
           <a:prstGeom prst="rect">
@@ -3402,8 +3591,14 @@
               </a:defRPr>
             </a:pPr>
             <a:r>
-              <a:t>jesyldah.github.io/ElimuMatch</a:t>
-            </a:r>
+              <a:rPr dirty="0"/>
+              <a:t>jesyldah.github.io/</a:t>
+            </a:r>
+            <a:r>
+              <a:rPr dirty="0" err="1"/>
+              <a:t>ElimuMatch</a:t>
+            </a:r>
+            <a:endParaRPr dirty="0"/>
           </a:p>
         </p:txBody>
       </p:sp>
@@ -3416,7 +3611,7 @@
 </file>
 
 <file path=ppt/slides/slide10.xml><?xml version="1.0" encoding="utf-8"?>
-<p:sld xmlns:a="http://schemas.openxmlformats.org/drawingml/2006/main" xmlns:p="http://schemas.openxmlformats.org/presentationml/2006/main" xmlns:r="http://schemas.openxmlformats.org/officeDocument/2006/relationships">
+<p:sld xmlns:a="http://schemas.openxmlformats.org/drawingml/2006/main" xmlns:r="http://schemas.openxmlformats.org/officeDocument/2006/relationships" xmlns:p="http://schemas.openxmlformats.org/presentationml/2006/main">
   <p:cSld>
     <p:bg>
       <p:bgPr>
@@ -3432,7 +3627,14 @@
         <p:cNvGrpSpPr/>
         <p:nvPr/>
       </p:nvGrpSpPr>
-      <p:grpSpPr/>
+      <p:grpSpPr>
+        <a:xfrm>
+          <a:off x="0" y="0"/>
+          <a:ext cx="0" cy="0"/>
+          <a:chOff x="0" y="0"/>
+          <a:chExt cx="0" cy="0"/>
+        </a:xfrm>
+      </p:grpSpPr>
       <p:sp>
         <p:nvSpPr>
           <p:cNvPr id="2" name="Rectangle 1"/>
@@ -3473,6 +3675,7 @@
           <a:lstStyle/>
           <a:p>
             <a:pPr algn="ctr"/>
+            <a:endParaRPr/>
           </a:p>
         </p:txBody>
       </p:sp>
@@ -3516,6 +3719,7 @@
           <a:lstStyle/>
           <a:p>
             <a:pPr algn="ctr"/>
+            <a:endParaRPr/>
           </a:p>
         </p:txBody>
       </p:sp>
@@ -3860,7 +4064,7 @@
         <p:spPr>
           <a:xfrm>
             <a:off x="6400800" y="1188720"/>
-            <a:ext cx="5029200" cy="5029200"/>
+            <a:ext cx="5029200" cy="2369880"/>
           </a:xfrm>
           <a:prstGeom prst="rect">
             <a:avLst/>
@@ -3882,6 +4086,7 @@
               </a:defRPr>
             </a:pPr>
             <a:r>
+              <a:rPr dirty="0"/>
               <a:t>Figure sources:</a:t>
             </a:r>
           </a:p>
@@ -3898,6 +4103,7 @@
               </a:defRPr>
             </a:pPr>
             <a:r>
+              <a:rPr dirty="0"/>
               <a:t>Slide 2: Author charts from UNESCO IICBA (2025) and KNBS (2025)</a:t>
             </a:r>
           </a:p>
@@ -3914,6 +4120,7 @@
               </a:defRPr>
             </a:pPr>
             <a:r>
+              <a:rPr dirty="0"/>
               <a:t>Slide 3: Illustrative positioning map (author)</a:t>
             </a:r>
           </a:p>
@@ -3930,6 +4137,7 @@
               </a:defRPr>
             </a:pPr>
             <a:r>
+              <a:rPr dirty="0"/>
               <a:t>Slide 4: Product layer diagram (author)</a:t>
             </a:r>
           </a:p>
@@ -3946,6 +4154,7 @@
               </a:defRPr>
             </a:pPr>
             <a:r>
+              <a:rPr dirty="0"/>
               <a:t>Slide 5: Gift journey and operations flow (author)</a:t>
             </a:r>
           </a:p>
@@ -3962,6 +4171,7 @@
               </a:defRPr>
             </a:pPr>
             <a:r>
+              <a:rPr dirty="0"/>
               <a:t>Slide 6: Model comparison from project pipeline on test data</a:t>
             </a:r>
           </a:p>
@@ -3978,6 +4188,7 @@
               </a:defRPr>
             </a:pPr>
             <a:r>
+              <a:rPr dirty="0"/>
               <a:t>Slide 7: Year-1 economics chart (illustrative, author)</a:t>
             </a:r>
           </a:p>
@@ -3993,51 +4204,7 @@
                 <a:latin typeface="Calibri"/>
               </a:defRPr>
             </a:pPr>
-          </a:p>
-          <a:p>
-            <a:pPr algn="l">
-              <a:spcBef>
-                <a:spcPts val="600"/>
-              </a:spcBef>
-              <a:defRPr sz="1200" b="1">
-                <a:solidFill>
-                  <a:srgbClr val="14213D"/>
-                </a:solidFill>
-                <a:latin typeface="Calibri"/>
-              </a:defRPr>
-            </a:pPr>
-            <a:r>
-              <a:t>AI-assisted drafting:</a:t>
-            </a:r>
-          </a:p>
-          <a:p>
-            <a:pPr algn="l">
-              <a:spcBef>
-                <a:spcPts val="600"/>
-              </a:spcBef>
-              <a:defRPr sz="1100" b="0">
-                <a:solidFill>
-                  <a:srgbClr val="14213D"/>
-                </a:solidFill>
-                <a:latin typeface="Calibri"/>
-              </a:defRPr>
-            </a:pPr>
-            <a:r>
-              <a:t>Report drafting supported by Cursor Auto (Composer) (Cursor, 2026). All decisions and claims are the author's.</a:t>
-            </a:r>
-          </a:p>
-          <a:p>
-            <a:pPr algn="l">
-              <a:spcBef>
-                <a:spcPts val="600"/>
-              </a:spcBef>
-              <a:defRPr sz="800" b="0">
-                <a:solidFill>
-                  <a:srgbClr val="14213D"/>
-                </a:solidFill>
-                <a:latin typeface="Calibri"/>
-              </a:defRPr>
-            </a:pPr>
+            <a:endParaRPr dirty="0"/>
           </a:p>
           <a:p>
             <a:pPr algn="l">
@@ -4052,6 +4219,7 @@
               </a:defRPr>
             </a:pPr>
             <a:r>
+              <a:rPr dirty="0"/>
               <a:t>All results are from proof-of-concept data (1,000 students). Not yet validated on live school records.</a:t>
             </a:r>
           </a:p>
@@ -4102,7 +4270,7 @@
 </file>
 
 <file path=ppt/slides/slide2.xml><?xml version="1.0" encoding="utf-8"?>
-<p:sld xmlns:a="http://schemas.openxmlformats.org/drawingml/2006/main" xmlns:p="http://schemas.openxmlformats.org/presentationml/2006/main" xmlns:r="http://schemas.openxmlformats.org/officeDocument/2006/relationships">
+<p:sld xmlns:a="http://schemas.openxmlformats.org/drawingml/2006/main" xmlns:r="http://schemas.openxmlformats.org/officeDocument/2006/relationships" xmlns:p="http://schemas.openxmlformats.org/presentationml/2006/main">
   <p:cSld>
     <p:bg>
       <p:bgPr>
@@ -4118,7 +4286,14 @@
         <p:cNvGrpSpPr/>
         <p:nvPr/>
       </p:nvGrpSpPr>
-      <p:grpSpPr/>
+      <p:grpSpPr>
+        <a:xfrm>
+          <a:off x="0" y="0"/>
+          <a:ext cx="0" cy="0"/>
+          <a:chOff x="0" y="0"/>
+          <a:chExt cx="0" cy="0"/>
+        </a:xfrm>
+      </p:grpSpPr>
       <p:sp>
         <p:nvSpPr>
           <p:cNvPr id="2" name="Rectangle 1"/>
@@ -4159,6 +4334,7 @@
           <a:lstStyle/>
           <a:p>
             <a:pPr algn="ctr"/>
+            <a:endParaRPr/>
           </a:p>
         </p:txBody>
       </p:sp>
@@ -4202,6 +4378,7 @@
           <a:lstStyle/>
           <a:p>
             <a:pPr algn="ctr"/>
+            <a:endParaRPr/>
           </a:p>
         </p:txBody>
       </p:sp>
@@ -4236,7 +4413,7 @@
               </a:defRPr>
             </a:pPr>
             <a:r>
-              <a:t>CONTEXT AND PROBLEM</a:t>
+              <a:t>PROBLEM</a:t>
             </a:r>
           </a:p>
         </p:txBody>
@@ -4250,7 +4427,7 @@
         <p:spPr>
           <a:xfrm>
             <a:off x="640080" y="640080"/>
-            <a:ext cx="10972800" cy="731520"/>
+            <a:ext cx="10972800" cy="830997"/>
           </a:xfrm>
           <a:prstGeom prst="rect">
             <a:avLst/>
@@ -4272,7 +4449,16 @@
               </a:defRPr>
             </a:pPr>
             <a:r>
-              <a:t>Kenya expanded access, but nearly half of students still do not finish secondary school</a:t>
+              <a:rPr dirty="0"/>
+              <a:t>Kenya</a:t>
+            </a:r>
+            <a:r>
+              <a:rPr lang="en-GB" dirty="0"/>
+              <a:t> has</a:t>
+            </a:r>
+            <a:r>
+              <a:rPr dirty="0"/>
+              <a:t> expanded access, but nearly half of students still do not finish secondary school</a:t>
             </a:r>
           </a:p>
         </p:txBody>
@@ -4422,7 +4608,7 @@
 </file>
 
 <file path=ppt/slides/slide3.xml><?xml version="1.0" encoding="utf-8"?>
-<p:sld xmlns:a="http://schemas.openxmlformats.org/drawingml/2006/main" xmlns:p="http://schemas.openxmlformats.org/presentationml/2006/main" xmlns:r="http://schemas.openxmlformats.org/officeDocument/2006/relationships">
+<p:sld xmlns:a="http://schemas.openxmlformats.org/drawingml/2006/main" xmlns:r="http://schemas.openxmlformats.org/officeDocument/2006/relationships" xmlns:p="http://schemas.openxmlformats.org/presentationml/2006/main">
   <p:cSld>
     <p:bg>
       <p:bgPr>
@@ -4438,7 +4624,14 @@
         <p:cNvGrpSpPr/>
         <p:nvPr/>
       </p:nvGrpSpPr>
-      <p:grpSpPr/>
+      <p:grpSpPr>
+        <a:xfrm>
+          <a:off x="0" y="0"/>
+          <a:ext cx="0" cy="0"/>
+          <a:chOff x="0" y="0"/>
+          <a:chExt cx="0" cy="0"/>
+        </a:xfrm>
+      </p:grpSpPr>
       <p:sp>
         <p:nvSpPr>
           <p:cNvPr id="2" name="Rectangle 1"/>
@@ -4479,6 +4672,7 @@
           <a:lstStyle/>
           <a:p>
             <a:pPr algn="ctr"/>
+            <a:endParaRPr/>
           </a:p>
         </p:txBody>
       </p:sp>
@@ -4522,6 +4716,7 @@
           <a:lstStyle/>
           <a:p>
             <a:pPr algn="ctr"/>
+            <a:endParaRPr/>
           </a:p>
         </p:txBody>
       </p:sp>
@@ -4556,7 +4751,7 @@
               </a:defRPr>
             </a:pPr>
             <a:r>
-              <a:t>EVIDENCE OF THE OPPORTUNITY</a:t>
+              <a:t>OPPORTUNITY</a:t>
             </a:r>
           </a:p>
         </p:txBody>
@@ -4652,6 +4847,7 @@
               </a:defRPr>
             </a:pPr>
             <a:r>
+              <a:rPr dirty="0"/>
               <a:t>How support is directed today:</a:t>
             </a:r>
           </a:p>
@@ -4668,6 +4864,7 @@
               </a:defRPr>
             </a:pPr>
             <a:r>
+              <a:rPr dirty="0"/>
               <a:t>•  Many NGO programs concentrate on arid and semi-arid lands (ASAL), while students elsewhere also face fee pressure and dropout risk.</a:t>
             </a:r>
           </a:p>
@@ -4684,6 +4881,7 @@
               </a:defRPr>
             </a:pPr>
             <a:r>
+              <a:rPr dirty="0"/>
               <a:t>•  Most individual donors rely on personal contacts, so students without connections are overlooked.</a:t>
             </a:r>
           </a:p>
@@ -4700,6 +4898,7 @@
               </a:defRPr>
             </a:pPr>
             <a:r>
+              <a:rPr dirty="0"/>
               <a:t>•  Bursary contests run once a year with heavy paperwork, leaving gaps the rest of the time.</a:t>
             </a:r>
           </a:p>
@@ -4716,6 +4915,7 @@
               </a:defRPr>
             </a:pPr>
             <a:r>
+              <a:rPr dirty="0"/>
               <a:t>•  Crowdfunding and school lists rarely rank who is most at risk of leaving.</a:t>
             </a:r>
           </a:p>
@@ -4731,6 +4931,7 @@
                 <a:latin typeface="Calibri"/>
               </a:defRPr>
             </a:pPr>
+            <a:endParaRPr dirty="0"/>
           </a:p>
           <a:p>
             <a:pPr algn="l">
@@ -4745,43 +4946,12 @@
               </a:defRPr>
             </a:pPr>
             <a:r>
-              <a:t>ElimuMatch covers all 47 counties: donors can choose any place, and priority follows measured risk, not geography alone.</a:t>
-            </a:r>
-          </a:p>
-        </p:txBody>
-      </p:sp>
-      <p:sp>
-        <p:nvSpPr>
-          <p:cNvPr id="8" name="TextBox 7"/>
-          <p:cNvSpPr txBox="1"/>
-          <p:nvPr/>
-        </p:nvSpPr>
-        <p:spPr>
-          <a:xfrm>
-            <a:off x="640080" y="6400800"/>
-            <a:ext cx="10972800" cy="365760"/>
-          </a:xfrm>
-          <a:prstGeom prst="rect">
-            <a:avLst/>
-          </a:prstGeom>
-          <a:noFill/>
-        </p:spPr>
-        <p:txBody>
-          <a:bodyPr wrap="square">
-            <a:spAutoFit/>
-          </a:bodyPr>
-          <a:lstStyle/>
-          <a:p>
-            <a:pPr algn="l">
-              <a:defRPr sz="1000" b="0">
-                <a:solidFill>
-                  <a:srgbClr val="5C6B73"/>
-                </a:solidFill>
-                <a:latin typeface="Calibri"/>
-              </a:defRPr>
-            </a:pPr>
-            <a:r>
-              <a:t>ASAL focus is a common NGO pattern; ElimuMatch does not claim ASAL work is unnecessary. Bursaries and ElimuMatch are complements.</a:t>
+              <a:rPr dirty="0" err="1"/>
+              <a:t>ElimuMatch</a:t>
+            </a:r>
+            <a:r>
+              <a:rPr dirty="0"/>
+              <a:t> covers all 47 counties: donors can choose any place, and priority follows measured risk, not geography alone.</a:t>
             </a:r>
           </a:p>
         </p:txBody>
@@ -4795,7 +4965,7 @@
 </file>
 
 <file path=ppt/slides/slide4.xml><?xml version="1.0" encoding="utf-8"?>
-<p:sld xmlns:a="http://schemas.openxmlformats.org/drawingml/2006/main" xmlns:p="http://schemas.openxmlformats.org/presentationml/2006/main" xmlns:r="http://schemas.openxmlformats.org/officeDocument/2006/relationships">
+<p:sld xmlns:a="http://schemas.openxmlformats.org/drawingml/2006/main" xmlns:r="http://schemas.openxmlformats.org/officeDocument/2006/relationships" xmlns:p="http://schemas.openxmlformats.org/presentationml/2006/main">
   <p:cSld>
     <p:bg>
       <p:bgPr>
@@ -4811,7 +4981,14 @@
         <p:cNvGrpSpPr/>
         <p:nvPr/>
       </p:nvGrpSpPr>
-      <p:grpSpPr/>
+      <p:grpSpPr>
+        <a:xfrm>
+          <a:off x="0" y="0"/>
+          <a:ext cx="0" cy="0"/>
+          <a:chOff x="0" y="0"/>
+          <a:chExt cx="0" cy="0"/>
+        </a:xfrm>
+      </p:grpSpPr>
       <p:sp>
         <p:nvSpPr>
           <p:cNvPr id="2" name="Rectangle 1"/>
@@ -4852,6 +5029,7 @@
           <a:lstStyle/>
           <a:p>
             <a:pPr algn="ctr"/>
+            <a:endParaRPr/>
           </a:p>
         </p:txBody>
       </p:sp>
@@ -4895,6 +5073,7 @@
           <a:lstStyle/>
           <a:p>
             <a:pPr algn="ctr"/>
+            <a:endParaRPr/>
           </a:p>
         </p:txBody>
       </p:sp>
@@ -5056,6 +5235,7 @@
                 <a:latin typeface="Calibri"/>
               </a:defRPr>
             </a:pPr>
+            <a:endParaRPr/>
           </a:p>
           <a:p>
             <a:pPr algn="l">
@@ -5101,6 +5281,7 @@
                 <a:latin typeface="Calibri"/>
               </a:defRPr>
             </a:pPr>
+            <a:endParaRPr/>
           </a:p>
           <a:p>
             <a:pPr algn="l">
@@ -5129,7 +5310,7 @@
         <p:spPr>
           <a:xfrm>
             <a:off x="640080" y="6400800"/>
-            <a:ext cx="10972800" cy="365760"/>
+            <a:ext cx="10972800" cy="246221"/>
           </a:xfrm>
           <a:prstGeom prst="rect">
             <a:avLst/>
@@ -5151,7 +5332,16 @@
               </a:defRPr>
             </a:pPr>
             <a:r>
-              <a:t>Privacy: donors see anonymized profiles only. Student identities are protected. Orphan status is never used as an input.</a:t>
+              <a:rPr dirty="0"/>
+              <a:t>Privacy: </a:t>
+            </a:r>
+            <a:r>
+              <a:rPr lang="en-GB" dirty="0"/>
+              <a:t>D</a:t>
+            </a:r>
+            <a:r>
+              <a:rPr dirty="0"/>
+              <a:t>onors see anonymized profiles only. Student identities are protected. </a:t>
             </a:r>
           </a:p>
         </p:txBody>
@@ -5165,7 +5355,7 @@
 </file>
 
 <file path=ppt/slides/slide5.xml><?xml version="1.0" encoding="utf-8"?>
-<p:sld xmlns:a="http://schemas.openxmlformats.org/drawingml/2006/main" xmlns:p="http://schemas.openxmlformats.org/presentationml/2006/main" xmlns:r="http://schemas.openxmlformats.org/officeDocument/2006/relationships">
+<p:sld xmlns:a="http://schemas.openxmlformats.org/drawingml/2006/main" xmlns:r="http://schemas.openxmlformats.org/officeDocument/2006/relationships" xmlns:p="http://schemas.openxmlformats.org/presentationml/2006/main">
   <p:cSld>
     <p:bg>
       <p:bgPr>
@@ -5181,7 +5371,14 @@
         <p:cNvGrpSpPr/>
         <p:nvPr/>
       </p:nvGrpSpPr>
-      <p:grpSpPr/>
+      <p:grpSpPr>
+        <a:xfrm>
+          <a:off x="0" y="0"/>
+          <a:ext cx="0" cy="0"/>
+          <a:chOff x="0" y="0"/>
+          <a:chExt cx="0" cy="0"/>
+        </a:xfrm>
+      </p:grpSpPr>
       <p:sp>
         <p:nvSpPr>
           <p:cNvPr id="2" name="Rectangle 1"/>
@@ -5222,6 +5419,7 @@
           <a:lstStyle/>
           <a:p>
             <a:pPr algn="ctr"/>
+            <a:endParaRPr/>
           </a:p>
         </p:txBody>
       </p:sp>
@@ -5265,6 +5463,7 @@
           <a:lstStyle/>
           <a:p>
             <a:pPr algn="ctr"/>
+            <a:endParaRPr/>
           </a:p>
         </p:txBody>
       </p:sp>
@@ -5461,7 +5660,7 @@
 </file>
 
 <file path=ppt/slides/slide6.xml><?xml version="1.0" encoding="utf-8"?>
-<p:sld xmlns:a="http://schemas.openxmlformats.org/drawingml/2006/main" xmlns:p="http://schemas.openxmlformats.org/presentationml/2006/main" xmlns:r="http://schemas.openxmlformats.org/officeDocument/2006/relationships">
+<p:sld xmlns:a="http://schemas.openxmlformats.org/drawingml/2006/main" xmlns:r="http://schemas.openxmlformats.org/officeDocument/2006/relationships" xmlns:p="http://schemas.openxmlformats.org/presentationml/2006/main">
   <p:cSld>
     <p:bg>
       <p:bgPr>
@@ -5477,7 +5676,14 @@
         <p:cNvGrpSpPr/>
         <p:nvPr/>
       </p:nvGrpSpPr>
-      <p:grpSpPr/>
+      <p:grpSpPr>
+        <a:xfrm>
+          <a:off x="0" y="0"/>
+          <a:ext cx="0" cy="0"/>
+          <a:chOff x="0" y="0"/>
+          <a:chExt cx="0" cy="0"/>
+        </a:xfrm>
+      </p:grpSpPr>
       <p:sp>
         <p:nvSpPr>
           <p:cNvPr id="2" name="Rectangle 1"/>
@@ -5518,6 +5724,7 @@
           <a:lstStyle/>
           <a:p>
             <a:pPr algn="ctr"/>
+            <a:endParaRPr/>
           </a:p>
         </p:txBody>
       </p:sp>
@@ -5561,6 +5768,7 @@
           <a:lstStyle/>
           <a:p>
             <a:pPr algn="ctr"/>
+            <a:endParaRPr/>
           </a:p>
         </p:txBody>
       </p:sp>
@@ -5722,6 +5930,7 @@
                 <a:latin typeface="Calibri"/>
               </a:defRPr>
             </a:pPr>
+            <a:endParaRPr/>
           </a:p>
           <a:p>
             <a:pPr algn="l">
@@ -5751,6 +5960,7 @@
                 <a:latin typeface="Calibri"/>
               </a:defRPr>
             </a:pPr>
+            <a:endParaRPr/>
           </a:p>
           <a:p>
             <a:pPr algn="l">
@@ -5779,7 +5989,7 @@
         <p:spPr>
           <a:xfrm>
             <a:off x="640080" y="6400800"/>
-            <a:ext cx="10972800" cy="365760"/>
+            <a:ext cx="10972800" cy="246221"/>
           </a:xfrm>
           <a:prstGeom prst="rect">
             <a:avLst/>
@@ -5801,7 +6011,8 @@
               </a:defRPr>
             </a:pPr>
             <a:r>
-              <a:t>Results from proof-of-concept data (1,000 students). Real school validation is the next step. Detection is weaker where nearly all students stay enrolled.</a:t>
+              <a:rPr dirty="0"/>
+              <a:t>Results from proof-of-concept data (1,000 students). Real school validation is the next step.</a:t>
             </a:r>
           </a:p>
         </p:txBody>
@@ -5815,7 +6026,7 @@
 </file>
 
 <file path=ppt/slides/slide7.xml><?xml version="1.0" encoding="utf-8"?>
-<p:sld xmlns:a="http://schemas.openxmlformats.org/drawingml/2006/main" xmlns:p="http://schemas.openxmlformats.org/presentationml/2006/main" xmlns:r="http://schemas.openxmlformats.org/officeDocument/2006/relationships">
+<p:sld xmlns:a="http://schemas.openxmlformats.org/drawingml/2006/main" xmlns:r="http://schemas.openxmlformats.org/officeDocument/2006/relationships" xmlns:p="http://schemas.openxmlformats.org/presentationml/2006/main">
   <p:cSld>
     <p:bg>
       <p:bgPr>
@@ -5831,7 +6042,14 @@
         <p:cNvGrpSpPr/>
         <p:nvPr/>
       </p:nvGrpSpPr>
-      <p:grpSpPr/>
+      <p:grpSpPr>
+        <a:xfrm>
+          <a:off x="0" y="0"/>
+          <a:ext cx="0" cy="0"/>
+          <a:chOff x="0" y="0"/>
+          <a:chExt cx="0" cy="0"/>
+        </a:xfrm>
+      </p:grpSpPr>
       <p:sp>
         <p:nvSpPr>
           <p:cNvPr id="2" name="Rectangle 1"/>
@@ -5872,6 +6090,7 @@
           <a:lstStyle/>
           <a:p>
             <a:pPr algn="ctr"/>
+            <a:endParaRPr/>
           </a:p>
         </p:txBody>
       </p:sp>
@@ -5915,6 +6134,7 @@
           <a:lstStyle/>
           <a:p>
             <a:pPr algn="ctr"/>
+            <a:endParaRPr/>
           </a:p>
         </p:txBody>
       </p:sp>
@@ -6060,6 +6280,7 @@
                 <a:latin typeface="Calibri"/>
               </a:defRPr>
             </a:pPr>
+            <a:endParaRPr/>
           </a:p>
           <a:p>
             <a:pPr algn="l">
@@ -6121,6 +6342,7 @@
                 <a:latin typeface="Calibri"/>
               </a:defRPr>
             </a:pPr>
+            <a:endParaRPr/>
           </a:p>
           <a:p>
             <a:pPr algn="l">
@@ -6166,6 +6388,7 @@
                 <a:latin typeface="Calibri"/>
               </a:defRPr>
             </a:pPr>
+            <a:endParaRPr/>
           </a:p>
           <a:p>
             <a:pPr algn="l">
@@ -6194,7 +6417,7 @@
         <p:spPr>
           <a:xfrm>
             <a:off x="640080" y="6400800"/>
-            <a:ext cx="10972800" cy="365760"/>
+            <a:ext cx="10972800" cy="246221"/>
           </a:xfrm>
           <a:prstGeom prst="rect">
             <a:avLst/>
@@ -6216,8 +6439,14 @@
               </a:defRPr>
             </a:pPr>
             <a:r>
-              <a:t>All figures are estimates for an illustrative pilot, not audited financials. Benefits depend on real outcomes, not test data.</a:t>
-            </a:r>
+              <a:rPr dirty="0"/>
+              <a:t>All figures are estimates for an illustrative pilot, not audited financials. Benefits depend on real outcomes</a:t>
+            </a:r>
+            <a:r>
+              <a:rPr lang="en-GB" dirty="0"/>
+              <a:t>.</a:t>
+            </a:r>
+            <a:endParaRPr dirty="0"/>
           </a:p>
         </p:txBody>
       </p:sp>
@@ -6230,7 +6459,7 @@
 </file>
 
 <file path=ppt/slides/slide8.xml><?xml version="1.0" encoding="utf-8"?>
-<p:sld xmlns:a="http://schemas.openxmlformats.org/drawingml/2006/main" xmlns:p="http://schemas.openxmlformats.org/presentationml/2006/main" xmlns:r="http://schemas.openxmlformats.org/officeDocument/2006/relationships">
+<p:sld xmlns:a="http://schemas.openxmlformats.org/drawingml/2006/main" xmlns:r="http://schemas.openxmlformats.org/officeDocument/2006/relationships" xmlns:p="http://schemas.openxmlformats.org/presentationml/2006/main">
   <p:cSld>
     <p:bg>
       <p:bgPr>
@@ -6246,7 +6475,14 @@
         <p:cNvGrpSpPr/>
         <p:nvPr/>
       </p:nvGrpSpPr>
-      <p:grpSpPr/>
+      <p:grpSpPr>
+        <a:xfrm>
+          <a:off x="0" y="0"/>
+          <a:ext cx="0" cy="0"/>
+          <a:chOff x="0" y="0"/>
+          <a:chExt cx="0" cy="0"/>
+        </a:xfrm>
+      </p:grpSpPr>
       <p:sp>
         <p:nvSpPr>
           <p:cNvPr id="2" name="Rectangle 1"/>
@@ -6287,6 +6523,7 @@
           <a:lstStyle/>
           <a:p>
             <a:pPr algn="ctr"/>
+            <a:endParaRPr/>
           </a:p>
         </p:txBody>
       </p:sp>
@@ -6330,6 +6567,7 @@
           <a:lstStyle/>
           <a:p>
             <a:pPr algn="ctr"/>
+            <a:endParaRPr/>
           </a:p>
         </p:txBody>
       </p:sp>
@@ -6413,8 +6651,8 @@
         </p:nvSpPr>
         <p:spPr>
           <a:xfrm>
-            <a:off x="640080" y="1645920"/>
-            <a:ext cx="2103120" cy="3154680"/>
+            <a:off x="411480" y="1645920"/>
+            <a:ext cx="1783080" cy="3154680"/>
           </a:xfrm>
           <a:prstGeom prst="rect">
             <a:avLst/>
@@ -6445,6 +6683,7 @@
           <a:lstStyle/>
           <a:p>
             <a:pPr algn="ctr"/>
+            <a:endParaRPr/>
           </a:p>
         </p:txBody>
       </p:sp>
@@ -6456,8 +6695,8 @@
         </p:nvSpPr>
         <p:spPr>
           <a:xfrm>
-            <a:off x="777240" y="1783080"/>
-            <a:ext cx="1828799" cy="365760"/>
+            <a:off x="502920" y="1755648"/>
+            <a:ext cx="1600200" cy="411480"/>
           </a:xfrm>
           <a:prstGeom prst="rect">
             <a:avLst/>
@@ -6471,7 +6710,7 @@
           <a:lstStyle/>
           <a:p>
             <a:pPr algn="l">
-              <a:defRPr sz="1500" b="1">
+              <a:defRPr sz="1300" b="1">
                 <a:solidFill>
                   <a:srgbClr val="FFFFFF"/>
                 </a:solidFill>
@@ -6492,8 +6731,8 @@
         </p:nvSpPr>
         <p:spPr>
           <a:xfrm>
-            <a:off x="777240" y="2286000"/>
-            <a:ext cx="1828799" cy="2011680"/>
+            <a:off x="502920" y="2240280"/>
+            <a:ext cx="1600200" cy="2057400"/>
           </a:xfrm>
           <a:prstGeom prst="rect">
             <a:avLst/>
@@ -6507,7 +6746,7 @@
           <a:lstStyle/>
           <a:p>
             <a:pPr algn="l">
-              <a:defRPr sz="1300" b="0">
+              <a:defRPr sz="1200" b="0">
                 <a:solidFill>
                   <a:srgbClr val="FFFFFF"/>
                 </a:solidFill>
@@ -6523,11 +6762,11 @@
             </a:r>
             <a:br/>
             <a:r>
-              <a:t>Set up data protection</a:t>
+              <a:t>Data protection and</a:t>
             </a:r>
             <a:br/>
             <a:r>
-              <a:t>and child safeguarding.</a:t>
+              <a:t>child safeguarding.</a:t>
             </a:r>
           </a:p>
         </p:txBody>
@@ -6540,8 +6779,8 @@
         </p:nvSpPr>
         <p:spPr>
           <a:xfrm>
-            <a:off x="777240" y="4297680"/>
-            <a:ext cx="1828799" cy="365760"/>
+            <a:off x="502920" y="4343400"/>
+            <a:ext cx="1600200" cy="261610"/>
           </a:xfrm>
           <a:prstGeom prst="rect">
             <a:avLst/>
@@ -6555,7 +6794,7 @@
           <a:lstStyle/>
           <a:p>
             <a:pPr algn="l">
-              <a:defRPr sz="1200" b="1">
+              <a:defRPr sz="1100" b="1">
                 <a:solidFill>
                   <a:srgbClr val="FFFFFF"/>
                 </a:solidFill>
@@ -6563,8 +6802,14 @@
               </a:defRPr>
             </a:pPr>
             <a:r>
-              <a:t>Months 0-2</a:t>
-            </a:r>
+              <a:rPr dirty="0"/>
+              <a:t>Months 0-</a:t>
+            </a:r>
+            <a:r>
+              <a:rPr lang="en-GB" dirty="0"/>
+              <a:t>4</a:t>
+            </a:r>
+            <a:endParaRPr dirty="0"/>
           </a:p>
         </p:txBody>
       </p:sp>
@@ -6576,8 +6821,8 @@
         </p:nvSpPr>
         <p:spPr>
           <a:xfrm>
-            <a:off x="2944368" y="1645920"/>
-            <a:ext cx="2103120" cy="3154680"/>
+            <a:off x="2322576" y="1645920"/>
+            <a:ext cx="1783080" cy="3154680"/>
           </a:xfrm>
           <a:prstGeom prst="rect">
             <a:avLst/>
@@ -6608,6 +6853,7 @@
           <a:lstStyle/>
           <a:p>
             <a:pPr algn="ctr"/>
+            <a:endParaRPr/>
           </a:p>
         </p:txBody>
       </p:sp>
@@ -6619,8 +6865,8 @@
         </p:nvSpPr>
         <p:spPr>
           <a:xfrm>
-            <a:off x="3081528" y="1783080"/>
-            <a:ext cx="1828799" cy="365760"/>
+            <a:off x="2414016" y="1755648"/>
+            <a:ext cx="1600200" cy="411480"/>
           </a:xfrm>
           <a:prstGeom prst="rect">
             <a:avLst/>
@@ -6634,7 +6880,7 @@
           <a:lstStyle/>
           <a:p>
             <a:pPr algn="l">
-              <a:defRPr sz="1500" b="1">
+              <a:defRPr sz="1300" b="1">
                 <a:solidFill>
                   <a:srgbClr val="FFFFFF"/>
                 </a:solidFill>
@@ -6642,7 +6888,8 @@
               </a:defRPr>
             </a:pPr>
             <a:r>
-              <a:t>2. Soft Pilot</a:t>
+              <a:rPr dirty="0"/>
+              <a:t>2. Partner Data</a:t>
             </a:r>
           </a:p>
         </p:txBody>
@@ -6655,8 +6902,8 @@
         </p:nvSpPr>
         <p:spPr>
           <a:xfrm>
-            <a:off x="3081528" y="2286000"/>
-            <a:ext cx="1828799" cy="2011680"/>
+            <a:off x="2414016" y="2240280"/>
+            <a:ext cx="1600200" cy="1200329"/>
           </a:xfrm>
           <a:prstGeom prst="rect">
             <a:avLst/>
@@ -6670,7 +6917,7 @@
           <a:lstStyle/>
           <a:p>
             <a:pPr algn="l">
-              <a:defRPr sz="1300" b="0">
+              <a:defRPr sz="1200" b="0">
                 <a:solidFill>
                   <a:srgbClr val="FFFFFF"/>
                 </a:solidFill>
@@ -6678,15 +6925,38 @@
               </a:defRPr>
             </a:pPr>
             <a:r>
-              <a:t>Rank students internally.</a:t>
-            </a:r>
-            <a:br/>
-            <a:r>
-              <a:t>Review every list before</a:t>
-            </a:r>
-            <a:br/>
-            <a:r>
-              <a:t>anything is made public.</a:t>
+              <a:rPr dirty="0"/>
+              <a:t>Collect school records</a:t>
+            </a:r>
+            <a:br>
+              <a:rPr dirty="0"/>
+            </a:br>
+            <a:r>
+              <a:rPr dirty="0"/>
+              <a:t>under the signed</a:t>
+            </a:r>
+            <a:br>
+              <a:rPr dirty="0"/>
+            </a:br>
+            <a:r>
+              <a:rPr dirty="0"/>
+              <a:t>agreements. Check quality,</a:t>
+            </a:r>
+            <a:r>
+              <a:rPr lang="en-GB" dirty="0"/>
+              <a:t> </a:t>
+            </a:r>
+            <a:r>
+              <a:rPr dirty="0"/>
+              <a:t>validate on real extracts,</a:t>
+            </a:r>
+            <a:r>
+              <a:rPr lang="en-GB" dirty="0"/>
+              <a:t> </a:t>
+            </a:r>
+            <a:r>
+              <a:rPr dirty="0"/>
+              <a:t>and set a termly refresh.</a:t>
             </a:r>
           </a:p>
         </p:txBody>
@@ -6699,8 +6969,8 @@
         </p:nvSpPr>
         <p:spPr>
           <a:xfrm>
-            <a:off x="3081528" y="4297680"/>
-            <a:ext cx="1828799" cy="365760"/>
+            <a:off x="2414016" y="4343400"/>
+            <a:ext cx="1600200" cy="320040"/>
           </a:xfrm>
           <a:prstGeom prst="rect">
             <a:avLst/>
@@ -6714,7 +6984,7 @@
           <a:lstStyle/>
           <a:p>
             <a:pPr algn="l">
-              <a:defRPr sz="1200" b="1">
+              <a:defRPr sz="1100" b="1">
                 <a:solidFill>
                   <a:srgbClr val="FFFFFF"/>
                 </a:solidFill>
@@ -6722,7 +6992,7 @@
               </a:defRPr>
             </a:pPr>
             <a:r>
-              <a:t>Term 1</a:t>
+              <a:t>Months 1-4</a:t>
             </a:r>
           </a:p>
         </p:txBody>
@@ -6735,8 +7005,8 @@
         </p:nvSpPr>
         <p:spPr>
           <a:xfrm>
-            <a:off x="5248656" y="1645920"/>
-            <a:ext cx="2103120" cy="3154680"/>
+            <a:off x="4233672" y="1645920"/>
+            <a:ext cx="1783080" cy="3154680"/>
           </a:xfrm>
           <a:prstGeom prst="rect">
             <a:avLst/>
@@ -6767,6 +7037,7 @@
           <a:lstStyle/>
           <a:p>
             <a:pPr algn="ctr"/>
+            <a:endParaRPr/>
           </a:p>
         </p:txBody>
       </p:sp>
@@ -6778,8 +7049,8 @@
         </p:nvSpPr>
         <p:spPr>
           <a:xfrm>
-            <a:off x="5385816" y="1783080"/>
-            <a:ext cx="1828799" cy="365760"/>
+            <a:off x="4325112" y="1755648"/>
+            <a:ext cx="1600200" cy="411480"/>
           </a:xfrm>
           <a:prstGeom prst="rect">
             <a:avLst/>
@@ -6793,7 +7064,7 @@
           <a:lstStyle/>
           <a:p>
             <a:pPr algn="l">
-              <a:defRPr sz="1500" b="1">
+              <a:defRPr sz="1300" b="1">
                 <a:solidFill>
                   <a:srgbClr val="FFFFFF"/>
                 </a:solidFill>
@@ -6801,7 +7072,7 @@
               </a:defRPr>
             </a:pPr>
             <a:r>
-              <a:t>3. Live Giving</a:t>
+              <a:t>3. Soft Pilot</a:t>
             </a:r>
           </a:p>
         </p:txBody>
@@ -6814,8 +7085,8 @@
         </p:nvSpPr>
         <p:spPr>
           <a:xfrm>
-            <a:off x="5385816" y="2286000"/>
-            <a:ext cx="1828799" cy="2011680"/>
+            <a:off x="4325112" y="2240280"/>
+            <a:ext cx="1600200" cy="2057400"/>
           </a:xfrm>
           <a:prstGeom prst="rect">
             <a:avLst/>
@@ -6829,7 +7100,7 @@
           <a:lstStyle/>
           <a:p>
             <a:pPr algn="l">
-              <a:defRPr sz="1300" b="0">
+              <a:defRPr sz="1200" b="0">
                 <a:solidFill>
                   <a:srgbClr val="FFFFFF"/>
                 </a:solidFill>
@@ -6837,19 +7108,19 @@
               </a:defRPr>
             </a:pPr>
             <a:r>
-              <a:t>Donors give through</a:t>
+              <a:t>Rank students on real</a:t>
             </a:r>
             <a:br/>
             <a:r>
-              <a:t>the platform. Money</a:t>
+              <a:t>data. Review every list</a:t>
             </a:r>
             <a:br/>
             <a:r>
-              <a:t>goes directly to</a:t>
+              <a:t>before anything is</a:t>
             </a:r>
             <a:br/>
             <a:r>
-              <a:t>school fee accounts.</a:t>
+              <a:t>made public.</a:t>
             </a:r>
           </a:p>
         </p:txBody>
@@ -6862,8 +7133,8 @@
         </p:nvSpPr>
         <p:spPr>
           <a:xfrm>
-            <a:off x="5385816" y="4297680"/>
-            <a:ext cx="1828799" cy="365760"/>
+            <a:off x="4325112" y="4343400"/>
+            <a:ext cx="1600200" cy="320040"/>
           </a:xfrm>
           <a:prstGeom prst="rect">
             <a:avLst/>
@@ -6877,7 +7148,7 @@
           <a:lstStyle/>
           <a:p>
             <a:pPr algn="l">
-              <a:defRPr sz="1200" b="1">
+              <a:defRPr sz="1100" b="1">
                 <a:solidFill>
                   <a:srgbClr val="FFFFFF"/>
                 </a:solidFill>
@@ -6885,7 +7156,7 @@
               </a:defRPr>
             </a:pPr>
             <a:r>
-              <a:t>Terms 1-2</a:t>
+              <a:t>Term 1</a:t>
             </a:r>
           </a:p>
         </p:txBody>
@@ -6898,8 +7169,172 @@
         </p:nvSpPr>
         <p:spPr>
           <a:xfrm>
-            <a:off x="7552944" y="1645920"/>
-            <a:ext cx="2103120" cy="3154680"/>
+            <a:off x="6144768" y="1645920"/>
+            <a:ext cx="1783080" cy="3154680"/>
+          </a:xfrm>
+          <a:prstGeom prst="rect">
+            <a:avLst/>
+          </a:prstGeom>
+          <a:solidFill>
+            <a:srgbClr val="1B7A5A"/>
+          </a:solidFill>
+          <a:ln>
+            <a:noFill/>
+          </a:ln>
+        </p:spPr>
+        <p:style>
+          <a:lnRef idx="1">
+            <a:schemeClr val="accent1"/>
+          </a:lnRef>
+          <a:fillRef idx="3">
+            <a:schemeClr val="accent1"/>
+          </a:fillRef>
+          <a:effectRef idx="2">
+            <a:schemeClr val="accent1"/>
+          </a:effectRef>
+          <a:fontRef idx="minor">
+            <a:schemeClr val="lt1"/>
+          </a:fontRef>
+        </p:style>
+        <p:txBody>
+          <a:bodyPr rtlCol="0" anchor="ctr"/>
+          <a:lstStyle/>
+          <a:p>
+            <a:pPr algn="ctr"/>
+            <a:endParaRPr/>
+          </a:p>
+        </p:txBody>
+      </p:sp>
+      <p:sp>
+        <p:nvSpPr>
+          <p:cNvPr id="19" name="TextBox 18"/>
+          <p:cNvSpPr txBox="1"/>
+          <p:nvPr/>
+        </p:nvSpPr>
+        <p:spPr>
+          <a:xfrm>
+            <a:off x="6236208" y="1755648"/>
+            <a:ext cx="1600200" cy="411480"/>
+          </a:xfrm>
+          <a:prstGeom prst="rect">
+            <a:avLst/>
+          </a:prstGeom>
+          <a:noFill/>
+        </p:spPr>
+        <p:txBody>
+          <a:bodyPr wrap="square">
+            <a:spAutoFit/>
+          </a:bodyPr>
+          <a:lstStyle/>
+          <a:p>
+            <a:pPr algn="l">
+              <a:defRPr sz="1300" b="1">
+                <a:solidFill>
+                  <a:srgbClr val="FFFFFF"/>
+                </a:solidFill>
+                <a:latin typeface="Calibri"/>
+              </a:defRPr>
+            </a:pPr>
+            <a:r>
+              <a:t>4. Live Giving</a:t>
+            </a:r>
+          </a:p>
+        </p:txBody>
+      </p:sp>
+      <p:sp>
+        <p:nvSpPr>
+          <p:cNvPr id="20" name="TextBox 19"/>
+          <p:cNvSpPr txBox="1"/>
+          <p:nvPr/>
+        </p:nvSpPr>
+        <p:spPr>
+          <a:xfrm>
+            <a:off x="6236208" y="2240280"/>
+            <a:ext cx="1600200" cy="2057400"/>
+          </a:xfrm>
+          <a:prstGeom prst="rect">
+            <a:avLst/>
+          </a:prstGeom>
+          <a:noFill/>
+        </p:spPr>
+        <p:txBody>
+          <a:bodyPr wrap="square">
+            <a:spAutoFit/>
+          </a:bodyPr>
+          <a:lstStyle/>
+          <a:p>
+            <a:pPr algn="l">
+              <a:defRPr sz="1200" b="0">
+                <a:solidFill>
+                  <a:srgbClr val="FFFFFF"/>
+                </a:solidFill>
+                <a:latin typeface="Calibri"/>
+              </a:defRPr>
+            </a:pPr>
+            <a:r>
+              <a:t>Donors give through</a:t>
+            </a:r>
+            <a:br/>
+            <a:r>
+              <a:t>the platform. Money</a:t>
+            </a:r>
+            <a:br/>
+            <a:r>
+              <a:t>goes to school fee</a:t>
+            </a:r>
+            <a:br/>
+            <a:r>
+              <a:t>accounts.</a:t>
+            </a:r>
+          </a:p>
+        </p:txBody>
+      </p:sp>
+      <p:sp>
+        <p:nvSpPr>
+          <p:cNvPr id="21" name="TextBox 20"/>
+          <p:cNvSpPr txBox="1"/>
+          <p:nvPr/>
+        </p:nvSpPr>
+        <p:spPr>
+          <a:xfrm>
+            <a:off x="6236208" y="4343400"/>
+            <a:ext cx="1600200" cy="320040"/>
+          </a:xfrm>
+          <a:prstGeom prst="rect">
+            <a:avLst/>
+          </a:prstGeom>
+          <a:noFill/>
+        </p:spPr>
+        <p:txBody>
+          <a:bodyPr wrap="square">
+            <a:spAutoFit/>
+          </a:bodyPr>
+          <a:lstStyle/>
+          <a:p>
+            <a:pPr algn="l">
+              <a:defRPr sz="1100" b="1">
+                <a:solidFill>
+                  <a:srgbClr val="FFFFFF"/>
+                </a:solidFill>
+                <a:latin typeface="Calibri"/>
+              </a:defRPr>
+            </a:pPr>
+            <a:r>
+              <a:t>Terms 1-2</a:t>
+            </a:r>
+          </a:p>
+        </p:txBody>
+      </p:sp>
+      <p:sp>
+        <p:nvSpPr>
+          <p:cNvPr id="22" name="Rectangle 21"/>
+          <p:cNvSpPr/>
+          <p:nvPr/>
+        </p:nvSpPr>
+        <p:spPr>
+          <a:xfrm>
+            <a:off x="8055863" y="1645920"/>
+            <a:ext cx="1783080" cy="3154680"/>
           </a:xfrm>
           <a:prstGeom prst="rect">
             <a:avLst/>
@@ -6930,19 +7365,20 @@
           <a:lstStyle/>
           <a:p>
             <a:pPr algn="ctr"/>
-          </a:p>
-        </p:txBody>
-      </p:sp>
-      <p:sp>
-        <p:nvSpPr>
-          <p:cNvPr id="19" name="TextBox 18"/>
+            <a:endParaRPr/>
+          </a:p>
+        </p:txBody>
+      </p:sp>
+      <p:sp>
+        <p:nvSpPr>
+          <p:cNvPr id="23" name="TextBox 22"/>
           <p:cNvSpPr txBox="1"/>
           <p:nvPr/>
         </p:nvSpPr>
         <p:spPr>
           <a:xfrm>
-            <a:off x="7690104" y="1783080"/>
-            <a:ext cx="1828799" cy="365760"/>
+            <a:off x="8147303" y="1755648"/>
+            <a:ext cx="1600200" cy="411480"/>
           </a:xfrm>
           <a:prstGeom prst="rect">
             <a:avLst/>
@@ -6956,7 +7392,7 @@
           <a:lstStyle/>
           <a:p>
             <a:pPr algn="l">
-              <a:defRPr sz="1500" b="1">
+              <a:defRPr sz="1300" b="1">
                 <a:solidFill>
                   <a:srgbClr val="14213D"/>
                 </a:solidFill>
@@ -6964,21 +7400,21 @@
               </a:defRPr>
             </a:pPr>
             <a:r>
-              <a:t>4. Measure</a:t>
-            </a:r>
-          </a:p>
-        </p:txBody>
-      </p:sp>
-      <p:sp>
-        <p:nvSpPr>
-          <p:cNvPr id="20" name="TextBox 19"/>
+              <a:t>5. Measure</a:t>
+            </a:r>
+          </a:p>
+        </p:txBody>
+      </p:sp>
+      <p:sp>
+        <p:nvSpPr>
+          <p:cNvPr id="24" name="TextBox 23"/>
           <p:cNvSpPr txBox="1"/>
           <p:nvPr/>
         </p:nvSpPr>
         <p:spPr>
           <a:xfrm>
-            <a:off x="7690104" y="2286000"/>
-            <a:ext cx="1828799" cy="2011680"/>
+            <a:off x="8147303" y="2240280"/>
+            <a:ext cx="1600200" cy="2057400"/>
           </a:xfrm>
           <a:prstGeom prst="rect">
             <a:avLst/>
@@ -6992,7 +7428,7 @@
           <a:lstStyle/>
           <a:p>
             <a:pPr algn="l">
-              <a:defRPr sz="1300" b="0">
+              <a:defRPr sz="1200" b="0">
                 <a:solidFill>
                   <a:srgbClr val="14213D"/>
                 </a:solidFill>
@@ -7004,29 +7440,29 @@
             </a:r>
             <a:br/>
             <a:r>
-              <a:t>students stay in school.</a:t>
+              <a:t>students stay enrolled.</a:t>
             </a:r>
             <a:br/>
             <a:r>
-              <a:t>Check payment accuracy</a:t>
+              <a:t>Check payments and</a:t>
             </a:r>
             <a:br/>
             <a:r>
-              <a:t>and fairness each term.</a:t>
-            </a:r>
-          </a:p>
-        </p:txBody>
-      </p:sp>
-      <p:sp>
-        <p:nvSpPr>
-          <p:cNvPr id="21" name="TextBox 20"/>
+              <a:t>fairness each term.</a:t>
+            </a:r>
+          </a:p>
+        </p:txBody>
+      </p:sp>
+      <p:sp>
+        <p:nvSpPr>
+          <p:cNvPr id="25" name="TextBox 24"/>
           <p:cNvSpPr txBox="1"/>
           <p:nvPr/>
         </p:nvSpPr>
         <p:spPr>
           <a:xfrm>
-            <a:off x="7690104" y="4297680"/>
-            <a:ext cx="1828799" cy="365760"/>
+            <a:off x="8147303" y="4343400"/>
+            <a:ext cx="1600200" cy="320040"/>
           </a:xfrm>
           <a:prstGeom prst="rect">
             <a:avLst/>
@@ -7040,7 +7476,7 @@
           <a:lstStyle/>
           <a:p>
             <a:pPr algn="l">
-              <a:defRPr sz="1200" b="1">
+              <a:defRPr sz="1100" b="1">
                 <a:solidFill>
                   <a:srgbClr val="14213D"/>
                 </a:solidFill>
@@ -7055,14 +7491,14 @@
       </p:sp>
       <p:sp>
         <p:nvSpPr>
-          <p:cNvPr id="22" name="Rectangle 21"/>
+          <p:cNvPr id="26" name="Rectangle 25"/>
           <p:cNvSpPr/>
           <p:nvPr/>
         </p:nvSpPr>
         <p:spPr>
           <a:xfrm>
-            <a:off x="9857232" y="1645920"/>
-            <a:ext cx="2103120" cy="3154680"/>
+            <a:off x="9966959" y="1645920"/>
+            <a:ext cx="1783080" cy="3154680"/>
           </a:xfrm>
           <a:prstGeom prst="rect">
             <a:avLst/>
@@ -7093,19 +7529,20 @@
           <a:lstStyle/>
           <a:p>
             <a:pPr algn="ctr"/>
-          </a:p>
-        </p:txBody>
-      </p:sp>
-      <p:sp>
-        <p:nvSpPr>
-          <p:cNvPr id="23" name="TextBox 22"/>
+            <a:endParaRPr/>
+          </a:p>
+        </p:txBody>
+      </p:sp>
+      <p:sp>
+        <p:nvSpPr>
+          <p:cNvPr id="27" name="TextBox 26"/>
           <p:cNvSpPr txBox="1"/>
           <p:nvPr/>
         </p:nvSpPr>
         <p:spPr>
           <a:xfrm>
-            <a:off x="9994392" y="1783080"/>
-            <a:ext cx="1828799" cy="365760"/>
+            <a:off x="10058399" y="1755648"/>
+            <a:ext cx="1600200" cy="411480"/>
           </a:xfrm>
           <a:prstGeom prst="rect">
             <a:avLst/>
@@ -7119,7 +7556,7 @@
           <a:lstStyle/>
           <a:p>
             <a:pPr algn="l">
-              <a:defRPr sz="1500" b="1">
+              <a:defRPr sz="1300" b="1">
                 <a:solidFill>
                   <a:srgbClr val="FFFFFF"/>
                 </a:solidFill>
@@ -7127,21 +7564,21 @@
               </a:defRPr>
             </a:pPr>
             <a:r>
-              <a:t>5. Scale Decision</a:t>
-            </a:r>
-          </a:p>
-        </p:txBody>
-      </p:sp>
-      <p:sp>
-        <p:nvSpPr>
-          <p:cNvPr id="24" name="TextBox 23"/>
+              <a:t>6. Scale Decision</a:t>
+            </a:r>
+          </a:p>
+        </p:txBody>
+      </p:sp>
+      <p:sp>
+        <p:nvSpPr>
+          <p:cNvPr id="28" name="TextBox 27"/>
           <p:cNvSpPr txBox="1"/>
           <p:nvPr/>
         </p:nvSpPr>
         <p:spPr>
           <a:xfrm>
-            <a:off x="9994392" y="2286000"/>
-            <a:ext cx="1828799" cy="2011680"/>
+            <a:off x="10058399" y="2240280"/>
+            <a:ext cx="1600200" cy="2057400"/>
           </a:xfrm>
           <a:prstGeom prst="rect">
             <a:avLst/>
@@ -7155,7 +7592,7 @@
           <a:lstStyle/>
           <a:p>
             <a:pPr algn="l">
-              <a:defRPr sz="1300" b="0">
+              <a:defRPr sz="1200" b="0">
                 <a:solidFill>
                   <a:srgbClr val="FFFFFF"/>
                 </a:solidFill>
@@ -7163,33 +7600,29 @@
               </a:defRPr>
             </a:pPr>
             <a:r>
-              <a:t>Add more schools or</a:t>
+              <a:t>Add schools or new</a:t>
             </a:r>
             <a:br/>
             <a:r>
-              <a:t>new types of support</a:t>
+              <a:t>support types only if</a:t>
             </a:r>
             <a:br/>
             <a:r>
-              <a:t>only if the pilot</a:t>
-            </a:r>
-            <a:br/>
-            <a:r>
-              <a:t>results justify it.</a:t>
-            </a:r>
-          </a:p>
-        </p:txBody>
-      </p:sp>
-      <p:sp>
-        <p:nvSpPr>
-          <p:cNvPr id="25" name="TextBox 24"/>
+              <a:t>pilot results justify it.</a:t>
+            </a:r>
+          </a:p>
+        </p:txBody>
+      </p:sp>
+      <p:sp>
+        <p:nvSpPr>
+          <p:cNvPr id="29" name="TextBox 28"/>
           <p:cNvSpPr txBox="1"/>
           <p:nvPr/>
         </p:nvSpPr>
         <p:spPr>
           <a:xfrm>
-            <a:off x="9994392" y="4297680"/>
-            <a:ext cx="1828799" cy="365760"/>
+            <a:off x="10058399" y="4343400"/>
+            <a:ext cx="1600200" cy="320040"/>
           </a:xfrm>
           <a:prstGeom prst="rect">
             <a:avLst/>
@@ -7203,7 +7636,7 @@
           <a:lstStyle/>
           <a:p>
             <a:pPr algn="l">
-              <a:defRPr sz="1200" b="1">
+              <a:defRPr sz="1100" b="1">
                 <a:solidFill>
                   <a:srgbClr val="FFFFFF"/>
                 </a:solidFill>
@@ -7218,14 +7651,14 @@
       </p:sp>
       <p:sp>
         <p:nvSpPr>
-          <p:cNvPr id="26" name="TextBox 25"/>
+          <p:cNvPr id="30" name="TextBox 29"/>
           <p:cNvSpPr txBox="1"/>
           <p:nvPr/>
         </p:nvSpPr>
         <p:spPr>
           <a:xfrm>
-            <a:off x="2761488" y="3108960"/>
-            <a:ext cx="182880" cy="365760"/>
+            <a:off x="2176272" y="3108960"/>
+            <a:ext cx="164592" cy="365760"/>
           </a:xfrm>
           <a:prstGeom prst="rect">
             <a:avLst/>
@@ -7239,7 +7672,7 @@
           <a:lstStyle/>
           <a:p>
             <a:pPr algn="ctr">
-              <a:defRPr sz="1400" b="0">
+              <a:defRPr sz="1100" b="0">
                 <a:solidFill>
                   <a:srgbClr val="1B7A5A"/>
                 </a:solidFill>
@@ -7254,14 +7687,14 @@
       </p:sp>
       <p:sp>
         <p:nvSpPr>
-          <p:cNvPr id="27" name="TextBox 26"/>
+          <p:cNvPr id="31" name="TextBox 30"/>
           <p:cNvSpPr txBox="1"/>
           <p:nvPr/>
         </p:nvSpPr>
         <p:spPr>
           <a:xfrm>
-            <a:off x="5065776" y="3108960"/>
-            <a:ext cx="182880" cy="365760"/>
+            <a:off x="4087368" y="3108960"/>
+            <a:ext cx="164592" cy="365760"/>
           </a:xfrm>
           <a:prstGeom prst="rect">
             <a:avLst/>
@@ -7275,7 +7708,7 @@
           <a:lstStyle/>
           <a:p>
             <a:pPr algn="ctr">
-              <a:defRPr sz="1400" b="0">
+              <a:defRPr sz="1100" b="0">
                 <a:solidFill>
                   <a:srgbClr val="1B7A5A"/>
                 </a:solidFill>
@@ -7290,14 +7723,14 @@
       </p:sp>
       <p:sp>
         <p:nvSpPr>
-          <p:cNvPr id="28" name="TextBox 27"/>
+          <p:cNvPr id="32" name="TextBox 31"/>
           <p:cNvSpPr txBox="1"/>
           <p:nvPr/>
         </p:nvSpPr>
         <p:spPr>
           <a:xfrm>
-            <a:off x="7370063" y="3108960"/>
-            <a:ext cx="182880" cy="365760"/>
+            <a:off x="5998464" y="3108960"/>
+            <a:ext cx="164592" cy="365760"/>
           </a:xfrm>
           <a:prstGeom prst="rect">
             <a:avLst/>
@@ -7311,7 +7744,7 @@
           <a:lstStyle/>
           <a:p>
             <a:pPr algn="ctr">
-              <a:defRPr sz="1400" b="0">
+              <a:defRPr sz="1100" b="0">
                 <a:solidFill>
                   <a:srgbClr val="1B7A5A"/>
                 </a:solidFill>
@@ -7326,14 +7759,14 @@
       </p:sp>
       <p:sp>
         <p:nvSpPr>
-          <p:cNvPr id="29" name="TextBox 28"/>
+          <p:cNvPr id="33" name="TextBox 32"/>
           <p:cNvSpPr txBox="1"/>
           <p:nvPr/>
         </p:nvSpPr>
         <p:spPr>
           <a:xfrm>
-            <a:off x="9674351" y="3108960"/>
-            <a:ext cx="182880" cy="365760"/>
+            <a:off x="7909560" y="3108960"/>
+            <a:ext cx="164592" cy="365760"/>
           </a:xfrm>
           <a:prstGeom prst="rect">
             <a:avLst/>
@@ -7347,7 +7780,7 @@
           <a:lstStyle/>
           <a:p>
             <a:pPr algn="ctr">
-              <a:defRPr sz="1400" b="0">
+              <a:defRPr sz="1100" b="0">
                 <a:solidFill>
                   <a:srgbClr val="1B7A5A"/>
                 </a:solidFill>
@@ -7362,7 +7795,43 @@
       </p:sp>
       <p:sp>
         <p:nvSpPr>
-          <p:cNvPr id="30" name="Rectangle 29"/>
+          <p:cNvPr id="34" name="TextBox 33"/>
+          <p:cNvSpPr txBox="1"/>
+          <p:nvPr/>
+        </p:nvSpPr>
+        <p:spPr>
+          <a:xfrm>
+            <a:off x="9820655" y="3108960"/>
+            <a:ext cx="164592" cy="365760"/>
+          </a:xfrm>
+          <a:prstGeom prst="rect">
+            <a:avLst/>
+          </a:prstGeom>
+          <a:noFill/>
+        </p:spPr>
+        <p:txBody>
+          <a:bodyPr wrap="square">
+            <a:spAutoFit/>
+          </a:bodyPr>
+          <a:lstStyle/>
+          <a:p>
+            <a:pPr algn="ctr">
+              <a:defRPr sz="1100" b="0">
+                <a:solidFill>
+                  <a:srgbClr val="1B7A5A"/>
+                </a:solidFill>
+                <a:latin typeface="Calibri"/>
+              </a:defRPr>
+            </a:pPr>
+            <a:r>
+              <a:t>▶</a:t>
+            </a:r>
+          </a:p>
+        </p:txBody>
+      </p:sp>
+      <p:sp>
+        <p:nvSpPr>
+          <p:cNvPr id="35" name="Rectangle 34"/>
           <p:cNvSpPr/>
           <p:nvPr/>
         </p:nvSpPr>
@@ -7400,12 +7869,13 @@
           <a:lstStyle/>
           <a:p>
             <a:pPr algn="ctr"/>
-          </a:p>
-        </p:txBody>
-      </p:sp>
-      <p:sp>
-        <p:nvSpPr>
-          <p:cNvPr id="31" name="TextBox 30"/>
+            <a:endParaRPr/>
+          </a:p>
+        </p:txBody>
+      </p:sp>
+      <p:sp>
+        <p:nvSpPr>
+          <p:cNvPr id="36" name="TextBox 35"/>
           <p:cNvSpPr txBox="1"/>
           <p:nvPr/>
         </p:nvSpPr>
@@ -7441,7 +7911,7 @@
       </p:sp>
       <p:sp>
         <p:nvSpPr>
-          <p:cNvPr id="32" name="Rectangle 31"/>
+          <p:cNvPr id="37" name="Rectangle 36"/>
           <p:cNvSpPr/>
           <p:nvPr/>
         </p:nvSpPr>
@@ -7479,12 +7949,13 @@
           <a:lstStyle/>
           <a:p>
             <a:pPr algn="ctr"/>
-          </a:p>
-        </p:txBody>
-      </p:sp>
-      <p:sp>
-        <p:nvSpPr>
-          <p:cNvPr id="33" name="TextBox 32"/>
+            <a:endParaRPr/>
+          </a:p>
+        </p:txBody>
+      </p:sp>
+      <p:sp>
+        <p:nvSpPr>
+          <p:cNvPr id="38" name="TextBox 37"/>
           <p:cNvSpPr txBox="1"/>
           <p:nvPr/>
         </p:nvSpPr>
@@ -7520,7 +7991,7 @@
       </p:sp>
       <p:sp>
         <p:nvSpPr>
-          <p:cNvPr id="34" name="Rectangle 33"/>
+          <p:cNvPr id="39" name="Rectangle 38"/>
           <p:cNvSpPr/>
           <p:nvPr/>
         </p:nvSpPr>
@@ -7558,12 +8029,13 @@
           <a:lstStyle/>
           <a:p>
             <a:pPr algn="ctr"/>
-          </a:p>
-        </p:txBody>
-      </p:sp>
-      <p:sp>
-        <p:nvSpPr>
-          <p:cNvPr id="35" name="TextBox 34"/>
+            <a:endParaRPr/>
+          </a:p>
+        </p:txBody>
+      </p:sp>
+      <p:sp>
+        <p:nvSpPr>
+          <p:cNvPr id="40" name="TextBox 39"/>
           <p:cNvSpPr txBox="1"/>
           <p:nvPr/>
         </p:nvSpPr>
@@ -7599,7 +8071,7 @@
       </p:sp>
       <p:sp>
         <p:nvSpPr>
-          <p:cNvPr id="36" name="Rectangle 35"/>
+          <p:cNvPr id="41" name="Rectangle 40"/>
           <p:cNvSpPr/>
           <p:nvPr/>
         </p:nvSpPr>
@@ -7637,12 +8109,13 @@
           <a:lstStyle/>
           <a:p>
             <a:pPr algn="ctr"/>
-          </a:p>
-        </p:txBody>
-      </p:sp>
-      <p:sp>
-        <p:nvSpPr>
-          <p:cNvPr id="37" name="TextBox 36"/>
+            <a:endParaRPr/>
+          </a:p>
+        </p:txBody>
+      </p:sp>
+      <p:sp>
+        <p:nvSpPr>
+          <p:cNvPr id="42" name="TextBox 41"/>
           <p:cNvSpPr txBox="1"/>
           <p:nvPr/>
         </p:nvSpPr>
@@ -7678,7 +8151,7 @@
       </p:sp>
       <p:sp>
         <p:nvSpPr>
-          <p:cNvPr id="38" name="TextBox 37"/>
+          <p:cNvPr id="43" name="TextBox 42"/>
           <p:cNvSpPr txBox="1"/>
           <p:nvPr/>
         </p:nvSpPr>
@@ -7721,7 +8194,7 @@
 </file>
 
 <file path=ppt/slides/slide9.xml><?xml version="1.0" encoding="utf-8"?>
-<p:sld xmlns:a="http://schemas.openxmlformats.org/drawingml/2006/main" xmlns:p="http://schemas.openxmlformats.org/presentationml/2006/main" xmlns:r="http://schemas.openxmlformats.org/officeDocument/2006/relationships">
+<p:sld xmlns:a="http://schemas.openxmlformats.org/drawingml/2006/main" xmlns:r="http://schemas.openxmlformats.org/officeDocument/2006/relationships" xmlns:p="http://schemas.openxmlformats.org/presentationml/2006/main">
   <p:cSld>
     <p:bg>
       <p:bgPr>
@@ -7737,7 +8210,14 @@
         <p:cNvGrpSpPr/>
         <p:nvPr/>
       </p:nvGrpSpPr>
-      <p:grpSpPr/>
+      <p:grpSpPr>
+        <a:xfrm>
+          <a:off x="0" y="0"/>
+          <a:ext cx="0" cy="0"/>
+          <a:chOff x="0" y="0"/>
+          <a:chExt cx="0" cy="0"/>
+        </a:xfrm>
+      </p:grpSpPr>
       <p:sp>
         <p:nvSpPr>
           <p:cNvPr id="2" name="Rectangle 1"/>
@@ -7778,6 +8258,7 @@
           <a:lstStyle/>
           <a:p>
             <a:pPr algn="ctr"/>
+            <a:endParaRPr/>
           </a:p>
         </p:txBody>
       </p:sp>
@@ -7821,6 +8302,7 @@
           <a:lstStyle/>
           <a:p>
             <a:pPr algn="ctr"/>
+            <a:endParaRPr/>
           </a:p>
         </p:txBody>
       </p:sp>

</xml_diff>